<commit_message>
CHA-26: deck slide 10 — custom Gemma gateway now trained (finetune/ tree)
Slide 10 updated from "in progress" to the shipped state: Gemma 3 270M
fine-tuned → merged → ONNX q4f16 → pushed to HF; 1,438/253 dataset with a
PRIVATE-recall ship gate; points reviewers to finetune/ (branch
finetune/gemma-gateway-270m) for code, data, and the prompt contract.

Co-Authored-By: Claude Opus 4.8 (1M context) <noreply@anthropic.com>
</commit_message>
<xml_diff>
--- a/docs/contxt-pitch.pptx
+++ b/docs/contxt-pitch.pptx
@@ -3509,7 +3509,7 @@
                 </a:solidFill>
                 <a:latin typeface="Arial"/>
               </a:rPr>
-              <a:t>Fine-tuning Gemma for the privacy gateway.</a:t>
+              <a:t>A fine-tuned Gemma gateway — trained, not theoretical.</a:t>
             </a:r>
           </a:p>
         </p:txBody>
@@ -3557,7 +3557,7 @@
                 </a:solidFill>
                 <a:latin typeface="Arial"/>
               </a:rPr>
-              <a:t>Tiny + local.</a:t>
+              <a:t>Custom-tuned.</a:t>
             </a:r>
             <a:r>
               <a:rPr sz="1800" b="0">
@@ -3566,7 +3566,7 @@
                 </a:solidFill>
                 <a:latin typeface="Arial"/>
               </a:rPr>
-              <a:t>  Gemma 3 270M runs entirely in the browser — no data leaves for tiering.</a:t>
+              <a:t>  Gemma 3 270M fine-tuned to emit the tier JSON, merged, exported to ONNX (q4f16, ~273 MB) and pushed to Hugging Face — runs fully in-browser.</a:t>
             </a:r>
           </a:p>
           <a:p>
@@ -3591,7 +3591,7 @@
                 </a:solidFill>
                 <a:latin typeface="Arial"/>
               </a:rPr>
-              <a:t>Safety floor.</a:t>
+              <a:t>Real dataset + ship gate.</a:t>
             </a:r>
             <a:r>
               <a:rPr sz="1800" b="0">
@@ -3600,7 +3600,7 @@
                 </a:solidFill>
                 <a:latin typeface="Arial"/>
               </a:rPr>
-              <a:t>  Deterministic rules catch crown jewels even if the model is unsure.</a:t>
+              <a:t>  1,438 train / 253 held-out rows (rules-oracle seed + synthetic hard cases); gated on PRIVATE-recall — safety-asymmetric by design.</a:t>
             </a:r>
           </a:p>
           <a:p>
@@ -3625,7 +3625,7 @@
                 </a:solidFill>
                 <a:latin typeface="Arial"/>
               </a:rPr>
-              <a:t>In progress.</a:t>
+              <a:t>See the work.</a:t>
             </a:r>
             <a:r>
               <a:rPr sz="1800" b="0">
@@ -3634,7 +3634,7 @@
                 </a:solidFill>
                 <a:latin typeface="Arial"/>
               </a:rPr>
-              <a:t>  A fine-tuned Gemma 270M to sharpen PRIVATE-vs-SHARED decisions on-device.</a:t>
+              <a:t>  Training code, dataset &amp; the single-source-of-truth prompt contract live in finetune/ — branch finetune/gemma-gateway-270m.</a:t>
             </a:r>
           </a:p>
         </p:txBody>

</xml_diff>

<commit_message>
docs: AMD MI300X compute proof — encoder classifier trained on ROCm 7.2 / PyTorch 2.9
</commit_message>
<xml_diff>
--- a/docs/contxt-pitch.pptx
+++ b/docs/contxt-pitch.pptx
@@ -4,20 +4,23 @@
   <p:sldMasterIdLst>
     <p:sldMasterId id="2147483648" r:id="rId1"/>
   </p:sldMasterIdLst>
+  <p:notesMasterIdLst>
+    <p:notesMasterId r:id="rId13"/>
+  </p:notesMasterIdLst>
   <p:sldIdLst>
-    <p:sldId id="256" r:id="rId7"/>
-    <p:sldId id="257" r:id="rId8"/>
-    <p:sldId id="258" r:id="rId9"/>
-    <p:sldId id="259" r:id="rId10"/>
-    <p:sldId id="260" r:id="rId11"/>
-    <p:sldId id="261" r:id="rId12"/>
-    <p:sldId id="262" r:id="rId13"/>
-    <p:sldId id="263" r:id="rId14"/>
-    <p:sldId id="264" r:id="rId15"/>
-    <p:sldId id="265" r:id="rId16"/>
-    <p:sldId id="266" r:id="rId17"/>
+    <p:sldId id="256" r:id="rId2"/>
+    <p:sldId id="257" r:id="rId3"/>
+    <p:sldId id="258" r:id="rId4"/>
+    <p:sldId id="259" r:id="rId5"/>
+    <p:sldId id="260" r:id="rId6"/>
+    <p:sldId id="261" r:id="rId7"/>
+    <p:sldId id="262" r:id="rId8"/>
+    <p:sldId id="263" r:id="rId9"/>
+    <p:sldId id="264" r:id="rId10"/>
+    <p:sldId id="265" r:id="rId11"/>
+    <p:sldId id="266" r:id="rId12"/>
   </p:sldIdLst>
-  <p:sldSz cx="12191695" cy="6858000" type="screen4x3"/>
+  <p:sldSz cx="12192000" cy="6858000"/>
   <p:notesSz cx="6858000" cy="9144000"/>
   <p:defaultTextStyle>
     <a:defPPr>
@@ -114,7 +117,457 @@
       </a:defRPr>
     </a:lvl9pPr>
   </p:defaultTextStyle>
+  <p:extLst>
+    <p:ext uri="{EFAFB233-063F-42B5-8137-9DF3F51BA10A}">
+      <p15:sldGuideLst xmlns:p15="http://schemas.microsoft.com/office/powerpoint/2012/main">
+        <p15:guide id="1" orient="horz" pos="2160">
+          <p15:clr>
+            <a:srgbClr val="A4A3A4"/>
+          </p15:clr>
+        </p15:guide>
+        <p15:guide id="2" pos="2880">
+          <p15:clr>
+            <a:srgbClr val="A4A3A4"/>
+          </p15:clr>
+        </p15:guide>
+      </p15:sldGuideLst>
+    </p:ext>
+  </p:extLst>
 </p:presentation>
+</file>
+
+<file path=ppt/notesMasters/notesMaster1.xml><?xml version="1.0" encoding="utf-8"?>
+<p:notesMaster xmlns:a="http://schemas.openxmlformats.org/drawingml/2006/main" xmlns:r="http://schemas.openxmlformats.org/officeDocument/2006/relationships" xmlns:p="http://schemas.openxmlformats.org/presentationml/2006/main">
+  <p:cSld>
+    <p:bg>
+      <p:bgRef idx="1001">
+        <a:schemeClr val="bg1"/>
+      </p:bgRef>
+    </p:bg>
+    <p:spTree>
+      <p:nvGrpSpPr>
+        <p:cNvPr id="1" name=""/>
+        <p:cNvGrpSpPr/>
+        <p:nvPr/>
+      </p:nvGrpSpPr>
+      <p:grpSpPr>
+        <a:xfrm>
+          <a:off x="0" y="0"/>
+          <a:ext cx="0" cy="0"/>
+          <a:chOff x="0" y="0"/>
+          <a:chExt cx="0" cy="0"/>
+        </a:xfrm>
+      </p:grpSpPr>
+      <p:sp>
+        <p:nvSpPr>
+          <p:cNvPr id="2" name="Header Placeholder 1"/>
+          <p:cNvSpPr>
+            <a:spLocks noGrp="1"/>
+          </p:cNvSpPr>
+          <p:nvPr>
+            <p:ph type="hdr" sz="quarter"/>
+          </p:nvPr>
+        </p:nvSpPr>
+        <p:spPr>
+          <a:xfrm>
+            <a:off x="0" y="0"/>
+            <a:ext cx="2971800" cy="458788"/>
+          </a:xfrm>
+          <a:prstGeom prst="rect">
+            <a:avLst/>
+          </a:prstGeom>
+        </p:spPr>
+        <p:txBody>
+          <a:bodyPr vert="horz" lIns="91440" tIns="45720" rIns="91440" bIns="45720" rtlCol="0"/>
+          <a:lstStyle>
+            <a:lvl1pPr algn="l">
+              <a:defRPr sz="1200"/>
+            </a:lvl1pPr>
+          </a:lstStyle>
+          <a:p>
+            <a:endParaRPr lang="en-US"/>
+          </a:p>
+        </p:txBody>
+      </p:sp>
+      <p:sp>
+        <p:nvSpPr>
+          <p:cNvPr id="3" name="Date Placeholder 2"/>
+          <p:cNvSpPr>
+            <a:spLocks noGrp="1"/>
+          </p:cNvSpPr>
+          <p:nvPr>
+            <p:ph type="dt" idx="1"/>
+          </p:nvPr>
+        </p:nvSpPr>
+        <p:spPr>
+          <a:xfrm>
+            <a:off x="3884613" y="0"/>
+            <a:ext cx="2971800" cy="458788"/>
+          </a:xfrm>
+          <a:prstGeom prst="rect">
+            <a:avLst/>
+          </a:prstGeom>
+        </p:spPr>
+        <p:txBody>
+          <a:bodyPr vert="horz" lIns="91440" tIns="45720" rIns="91440" bIns="45720" rtlCol="0"/>
+          <a:lstStyle>
+            <a:lvl1pPr algn="r">
+              <a:defRPr sz="1200"/>
+            </a:lvl1pPr>
+          </a:lstStyle>
+          <a:p>
+            <a:fld id="{53B60C40-9780-7A44-80AD-4BBD17A662F0}" type="datetimeFigureOut">
+              <a:rPr lang="en-US" smtClean="0"/>
+              <a:t>7/13/26</a:t>
+            </a:fld>
+            <a:endParaRPr lang="en-US"/>
+          </a:p>
+        </p:txBody>
+      </p:sp>
+      <p:sp>
+        <p:nvSpPr>
+          <p:cNvPr id="4" name="Slide Image Placeholder 3"/>
+          <p:cNvSpPr>
+            <a:spLocks noGrp="1" noRot="1" noChangeAspect="1"/>
+          </p:cNvSpPr>
+          <p:nvPr>
+            <p:ph type="sldImg" idx="2"/>
+          </p:nvPr>
+        </p:nvSpPr>
+        <p:spPr>
+          <a:xfrm>
+            <a:off x="685800" y="1143000"/>
+            <a:ext cx="5486400" cy="3086100"/>
+          </a:xfrm>
+          <a:prstGeom prst="rect">
+            <a:avLst/>
+          </a:prstGeom>
+          <a:noFill/>
+          <a:ln w="12700">
+            <a:solidFill>
+              <a:prstClr val="black"/>
+            </a:solidFill>
+          </a:ln>
+        </p:spPr>
+        <p:txBody>
+          <a:bodyPr vert="horz" lIns="91440" tIns="45720" rIns="91440" bIns="45720" rtlCol="0" anchor="ctr"/>
+          <a:lstStyle/>
+          <a:p>
+            <a:endParaRPr lang="en-US"/>
+          </a:p>
+        </p:txBody>
+      </p:sp>
+      <p:sp>
+        <p:nvSpPr>
+          <p:cNvPr id="5" name="Notes Placeholder 4"/>
+          <p:cNvSpPr>
+            <a:spLocks noGrp="1"/>
+          </p:cNvSpPr>
+          <p:nvPr>
+            <p:ph type="body" sz="quarter" idx="3"/>
+          </p:nvPr>
+        </p:nvSpPr>
+        <p:spPr>
+          <a:xfrm>
+            <a:off x="685800" y="4400550"/>
+            <a:ext cx="5486400" cy="3600450"/>
+          </a:xfrm>
+          <a:prstGeom prst="rect">
+            <a:avLst/>
+          </a:prstGeom>
+        </p:spPr>
+        <p:txBody>
+          <a:bodyPr vert="horz" lIns="91440" tIns="45720" rIns="91440" bIns="45720" rtlCol="0"/>
+          <a:lstStyle/>
+          <a:p>
+            <a:pPr lvl="0"/>
+            <a:r>
+              <a:rPr lang="en-GB"/>
+              <a:t>Click to edit Master text styles</a:t>
+            </a:r>
+          </a:p>
+          <a:p>
+            <a:pPr lvl="1"/>
+            <a:r>
+              <a:rPr lang="en-GB"/>
+              <a:t>Second level</a:t>
+            </a:r>
+          </a:p>
+          <a:p>
+            <a:pPr lvl="2"/>
+            <a:r>
+              <a:rPr lang="en-GB"/>
+              <a:t>Third level</a:t>
+            </a:r>
+          </a:p>
+          <a:p>
+            <a:pPr lvl="3"/>
+            <a:r>
+              <a:rPr lang="en-GB"/>
+              <a:t>Fourth level</a:t>
+            </a:r>
+          </a:p>
+          <a:p>
+            <a:pPr lvl="4"/>
+            <a:r>
+              <a:rPr lang="en-GB"/>
+              <a:t>Fifth level</a:t>
+            </a:r>
+            <a:endParaRPr lang="en-US"/>
+          </a:p>
+        </p:txBody>
+      </p:sp>
+      <p:sp>
+        <p:nvSpPr>
+          <p:cNvPr id="6" name="Footer Placeholder 5"/>
+          <p:cNvSpPr>
+            <a:spLocks noGrp="1"/>
+          </p:cNvSpPr>
+          <p:nvPr>
+            <p:ph type="ftr" sz="quarter" idx="4"/>
+          </p:nvPr>
+        </p:nvSpPr>
+        <p:spPr>
+          <a:xfrm>
+            <a:off x="0" y="8685213"/>
+            <a:ext cx="2971800" cy="458787"/>
+          </a:xfrm>
+          <a:prstGeom prst="rect">
+            <a:avLst/>
+          </a:prstGeom>
+        </p:spPr>
+        <p:txBody>
+          <a:bodyPr vert="horz" lIns="91440" tIns="45720" rIns="91440" bIns="45720" rtlCol="0" anchor="b"/>
+          <a:lstStyle>
+            <a:lvl1pPr algn="l">
+              <a:defRPr sz="1200"/>
+            </a:lvl1pPr>
+          </a:lstStyle>
+          <a:p>
+            <a:endParaRPr lang="en-US"/>
+          </a:p>
+        </p:txBody>
+      </p:sp>
+      <p:sp>
+        <p:nvSpPr>
+          <p:cNvPr id="7" name="Slide Number Placeholder 6"/>
+          <p:cNvSpPr>
+            <a:spLocks noGrp="1"/>
+          </p:cNvSpPr>
+          <p:nvPr>
+            <p:ph type="sldNum" sz="quarter" idx="5"/>
+          </p:nvPr>
+        </p:nvSpPr>
+        <p:spPr>
+          <a:xfrm>
+            <a:off x="3884613" y="8685213"/>
+            <a:ext cx="2971800" cy="458787"/>
+          </a:xfrm>
+          <a:prstGeom prst="rect">
+            <a:avLst/>
+          </a:prstGeom>
+        </p:spPr>
+        <p:txBody>
+          <a:bodyPr vert="horz" lIns="91440" tIns="45720" rIns="91440" bIns="45720" rtlCol="0" anchor="b"/>
+          <a:lstStyle>
+            <a:lvl1pPr algn="r">
+              <a:defRPr sz="1200"/>
+            </a:lvl1pPr>
+          </a:lstStyle>
+          <a:p>
+            <a:fld id="{4CE9FA5B-1D5B-504D-A09B-02C73B608BB8}" type="slidenum">
+              <a:rPr lang="en-US" smtClean="0"/>
+              <a:t>‹#›</a:t>
+            </a:fld>
+            <a:endParaRPr lang="en-US"/>
+          </a:p>
+        </p:txBody>
+      </p:sp>
+    </p:spTree>
+    <p:extLst>
+      <p:ext uri="{BB962C8B-B14F-4D97-AF65-F5344CB8AC3E}">
+        <p14:creationId xmlns:p14="http://schemas.microsoft.com/office/powerpoint/2010/main" val="2723740922"/>
+      </p:ext>
+    </p:extLst>
+  </p:cSld>
+  <p:clrMap bg1="lt1" tx1="dk1" bg2="lt2" tx2="dk2" accent1="accent1" accent2="accent2" accent3="accent3" accent4="accent4" accent5="accent5" accent6="accent6" hlink="hlink" folHlink="folHlink"/>
+  <p:notesStyle>
+    <a:lvl1pPr marL="0" algn="l" defTabSz="914400" rtl="0" eaLnBrk="1" latinLnBrk="0" hangingPunct="1">
+      <a:defRPr sz="1200" kern="1200">
+        <a:solidFill>
+          <a:schemeClr val="tx1"/>
+        </a:solidFill>
+        <a:latin typeface="+mn-lt"/>
+        <a:ea typeface="+mn-ea"/>
+        <a:cs typeface="+mn-cs"/>
+      </a:defRPr>
+    </a:lvl1pPr>
+    <a:lvl2pPr marL="457200" algn="l" defTabSz="914400" rtl="0" eaLnBrk="1" latinLnBrk="0" hangingPunct="1">
+      <a:defRPr sz="1200" kern="1200">
+        <a:solidFill>
+          <a:schemeClr val="tx1"/>
+        </a:solidFill>
+        <a:latin typeface="+mn-lt"/>
+        <a:ea typeface="+mn-ea"/>
+        <a:cs typeface="+mn-cs"/>
+      </a:defRPr>
+    </a:lvl2pPr>
+    <a:lvl3pPr marL="914400" algn="l" defTabSz="914400" rtl="0" eaLnBrk="1" latinLnBrk="0" hangingPunct="1">
+      <a:defRPr sz="1200" kern="1200">
+        <a:solidFill>
+          <a:schemeClr val="tx1"/>
+        </a:solidFill>
+        <a:latin typeface="+mn-lt"/>
+        <a:ea typeface="+mn-ea"/>
+        <a:cs typeface="+mn-cs"/>
+      </a:defRPr>
+    </a:lvl3pPr>
+    <a:lvl4pPr marL="1371600" algn="l" defTabSz="914400" rtl="0" eaLnBrk="1" latinLnBrk="0" hangingPunct="1">
+      <a:defRPr sz="1200" kern="1200">
+        <a:solidFill>
+          <a:schemeClr val="tx1"/>
+        </a:solidFill>
+        <a:latin typeface="+mn-lt"/>
+        <a:ea typeface="+mn-ea"/>
+        <a:cs typeface="+mn-cs"/>
+      </a:defRPr>
+    </a:lvl4pPr>
+    <a:lvl5pPr marL="1828800" algn="l" defTabSz="914400" rtl="0" eaLnBrk="1" latinLnBrk="0" hangingPunct="1">
+      <a:defRPr sz="1200" kern="1200">
+        <a:solidFill>
+          <a:schemeClr val="tx1"/>
+        </a:solidFill>
+        <a:latin typeface="+mn-lt"/>
+        <a:ea typeface="+mn-ea"/>
+        <a:cs typeface="+mn-cs"/>
+      </a:defRPr>
+    </a:lvl5pPr>
+    <a:lvl6pPr marL="2286000" algn="l" defTabSz="914400" rtl="0" eaLnBrk="1" latinLnBrk="0" hangingPunct="1">
+      <a:defRPr sz="1200" kern="1200">
+        <a:solidFill>
+          <a:schemeClr val="tx1"/>
+        </a:solidFill>
+        <a:latin typeface="+mn-lt"/>
+        <a:ea typeface="+mn-ea"/>
+        <a:cs typeface="+mn-cs"/>
+      </a:defRPr>
+    </a:lvl6pPr>
+    <a:lvl7pPr marL="2743200" algn="l" defTabSz="914400" rtl="0" eaLnBrk="1" latinLnBrk="0" hangingPunct="1">
+      <a:defRPr sz="1200" kern="1200">
+        <a:solidFill>
+          <a:schemeClr val="tx1"/>
+        </a:solidFill>
+        <a:latin typeface="+mn-lt"/>
+        <a:ea typeface="+mn-ea"/>
+        <a:cs typeface="+mn-cs"/>
+      </a:defRPr>
+    </a:lvl7pPr>
+    <a:lvl8pPr marL="3200400" algn="l" defTabSz="914400" rtl="0" eaLnBrk="1" latinLnBrk="0" hangingPunct="1">
+      <a:defRPr sz="1200" kern="1200">
+        <a:solidFill>
+          <a:schemeClr val="tx1"/>
+        </a:solidFill>
+        <a:latin typeface="+mn-lt"/>
+        <a:ea typeface="+mn-ea"/>
+        <a:cs typeface="+mn-cs"/>
+      </a:defRPr>
+    </a:lvl8pPr>
+    <a:lvl9pPr marL="3657600" algn="l" defTabSz="914400" rtl="0" eaLnBrk="1" latinLnBrk="0" hangingPunct="1">
+      <a:defRPr sz="1200" kern="1200">
+        <a:solidFill>
+          <a:schemeClr val="tx1"/>
+        </a:solidFill>
+        <a:latin typeface="+mn-lt"/>
+        <a:ea typeface="+mn-ea"/>
+        <a:cs typeface="+mn-cs"/>
+      </a:defRPr>
+    </a:lvl9pPr>
+  </p:notesStyle>
+</p:notesMaster>
+</file>
+
+<file path=ppt/notesSlides/notesSlide1.xml><?xml version="1.0" encoding="utf-8"?>
+<p:notes xmlns:a="http://schemas.openxmlformats.org/drawingml/2006/main" xmlns:r="http://schemas.openxmlformats.org/officeDocument/2006/relationships" xmlns:p="http://schemas.openxmlformats.org/presentationml/2006/main">
+  <p:cSld>
+    <p:spTree>
+      <p:nvGrpSpPr>
+        <p:cNvPr id="1" name=""/>
+        <p:cNvGrpSpPr/>
+        <p:nvPr/>
+      </p:nvGrpSpPr>
+      <p:grpSpPr>
+        <a:xfrm>
+          <a:off x="0" y="0"/>
+          <a:ext cx="0" cy="0"/>
+          <a:chOff x="0" y="0"/>
+          <a:chExt cx="0" cy="0"/>
+        </a:xfrm>
+      </p:grpSpPr>
+      <p:sp>
+        <p:nvSpPr>
+          <p:cNvPr id="2" name="Slide Image Placeholder 1"/>
+          <p:cNvSpPr>
+            <a:spLocks noGrp="1" noRot="1" noChangeAspect="1"/>
+          </p:cNvSpPr>
+          <p:nvPr>
+            <p:ph type="sldImg"/>
+          </p:nvPr>
+        </p:nvSpPr>
+        <p:spPr/>
+      </p:sp>
+      <p:sp>
+        <p:nvSpPr>
+          <p:cNvPr id="3" name="Notes Placeholder 2"/>
+          <p:cNvSpPr>
+            <a:spLocks noGrp="1"/>
+          </p:cNvSpPr>
+          <p:nvPr>
+            <p:ph type="body" idx="1"/>
+          </p:nvPr>
+        </p:nvSpPr>
+        <p:spPr/>
+        <p:txBody>
+          <a:bodyPr/>
+          <a:lstStyle/>
+          <a:p>
+            <a:endParaRPr lang="en-US"/>
+          </a:p>
+        </p:txBody>
+      </p:sp>
+      <p:sp>
+        <p:nvSpPr>
+          <p:cNvPr id="4" name="Slide Number Placeholder 3"/>
+          <p:cNvSpPr>
+            <a:spLocks noGrp="1"/>
+          </p:cNvSpPr>
+          <p:nvPr>
+            <p:ph type="sldNum" sz="quarter" idx="5"/>
+          </p:nvPr>
+        </p:nvSpPr>
+        <p:spPr/>
+        <p:txBody>
+          <a:bodyPr/>
+          <a:lstStyle/>
+          <a:p>
+            <a:fld id="{4CE9FA5B-1D5B-504D-A09B-02C73B608BB8}" type="slidenum">
+              <a:rPr lang="en-US" smtClean="0"/>
+              <a:t>1</a:t>
+            </a:fld>
+            <a:endParaRPr lang="en-US"/>
+          </a:p>
+        </p:txBody>
+      </p:sp>
+    </p:spTree>
+    <p:extLst>
+      <p:ext uri="{BB962C8B-B14F-4D97-AF65-F5344CB8AC3E}">
+        <p14:creationId xmlns:p14="http://schemas.microsoft.com/office/powerpoint/2010/main" val="1466495103"/>
+      </p:ext>
+    </p:extLst>
+  </p:cSld>
+  <p:clrMapOvr>
+    <a:masterClrMapping/>
+  </p:clrMapOvr>
+</p:notes>
 </file>
 
 <file path=ppt/slideLayouts/slideLayout1.xml><?xml version="1.0" encoding="utf-8"?>
@@ -155,10 +608,9 @@
           <a:lstStyle/>
           <a:p>
             <a:r>
-              <a:rPr lang="en-US" smtClean="0"/>
+              <a:rPr lang="en-US"/>
               <a:t>Click to edit Master title style</a:t>
             </a:r>
-            <a:endParaRPr lang="en-US"/>
           </a:p>
         </p:txBody>
       </p:sp>
@@ -274,10 +726,9 @@
           </a:lstStyle>
           <a:p>
             <a:r>
-              <a:rPr lang="en-US" smtClean="0"/>
+              <a:rPr lang="en-US"/>
               <a:t>Click to edit Master subtitle style</a:t>
             </a:r>
-            <a:endParaRPr lang="en-US"/>
           </a:p>
         </p:txBody>
       </p:sp>
@@ -298,7 +749,7 @@
           <a:p>
             <a:fld id="{5BCAD085-E8A6-8845-BD4E-CB4CCA059FC4}" type="datetimeFigureOut">
               <a:rPr lang="en-US" smtClean="0"/>
-              <a:t>1/27/13</a:t>
+              <a:t>7/13/26</a:t>
             </a:fld>
             <a:endParaRPr lang="en-US"/>
           </a:p>
@@ -392,10 +843,9 @@
           <a:lstStyle/>
           <a:p>
             <a:r>
-              <a:rPr lang="en-US" smtClean="0"/>
+              <a:rPr lang="en-US"/>
               <a:t>Click to edit Master title style</a:t>
             </a:r>
-            <a:endParaRPr lang="en-US"/>
           </a:p>
         </p:txBody>
       </p:sp>
@@ -416,38 +866,37 @@
           <a:p>
             <a:pPr lvl="0"/>
             <a:r>
-              <a:rPr lang="en-US" smtClean="0"/>
+              <a:rPr lang="en-US"/>
               <a:t>Click to edit Master text styles</a:t>
             </a:r>
           </a:p>
           <a:p>
             <a:pPr lvl="1"/>
             <a:r>
-              <a:rPr lang="en-US" smtClean="0"/>
+              <a:rPr lang="en-US"/>
               <a:t>Second level</a:t>
             </a:r>
           </a:p>
           <a:p>
             <a:pPr lvl="2"/>
             <a:r>
-              <a:rPr lang="en-US" smtClean="0"/>
+              <a:rPr lang="en-US"/>
               <a:t>Third level</a:t>
             </a:r>
           </a:p>
           <a:p>
             <a:pPr lvl="3"/>
             <a:r>
-              <a:rPr lang="en-US" smtClean="0"/>
+              <a:rPr lang="en-US"/>
               <a:t>Fourth level</a:t>
             </a:r>
           </a:p>
           <a:p>
             <a:pPr lvl="4"/>
             <a:r>
-              <a:rPr lang="en-US" smtClean="0"/>
+              <a:rPr lang="en-US"/>
               <a:t>Fifth level</a:t>
             </a:r>
-            <a:endParaRPr lang="en-US"/>
           </a:p>
         </p:txBody>
       </p:sp>
@@ -468,7 +917,7 @@
           <a:p>
             <a:fld id="{5BCAD085-E8A6-8845-BD4E-CB4CCA059FC4}" type="datetimeFigureOut">
               <a:rPr lang="en-US" smtClean="0"/>
-              <a:t>1/27/13</a:t>
+              <a:t>7/13/26</a:t>
             </a:fld>
             <a:endParaRPr lang="en-US"/>
           </a:p>
@@ -567,10 +1016,9 @@
           <a:lstStyle/>
           <a:p>
             <a:r>
-              <a:rPr lang="en-US" smtClean="0"/>
+              <a:rPr lang="en-US"/>
               <a:t>Click to edit Master title style</a:t>
             </a:r>
-            <a:endParaRPr lang="en-US"/>
           </a:p>
         </p:txBody>
       </p:sp>
@@ -596,38 +1044,37 @@
           <a:p>
             <a:pPr lvl="0"/>
             <a:r>
-              <a:rPr lang="en-US" smtClean="0"/>
+              <a:rPr lang="en-US"/>
               <a:t>Click to edit Master text styles</a:t>
             </a:r>
           </a:p>
           <a:p>
             <a:pPr lvl="1"/>
             <a:r>
-              <a:rPr lang="en-US" smtClean="0"/>
+              <a:rPr lang="en-US"/>
               <a:t>Second level</a:t>
             </a:r>
           </a:p>
           <a:p>
             <a:pPr lvl="2"/>
             <a:r>
-              <a:rPr lang="en-US" smtClean="0"/>
+              <a:rPr lang="en-US"/>
               <a:t>Third level</a:t>
             </a:r>
           </a:p>
           <a:p>
             <a:pPr lvl="3"/>
             <a:r>
-              <a:rPr lang="en-US" smtClean="0"/>
+              <a:rPr lang="en-US"/>
               <a:t>Fourth level</a:t>
             </a:r>
           </a:p>
           <a:p>
             <a:pPr lvl="4"/>
             <a:r>
-              <a:rPr lang="en-US" smtClean="0"/>
+              <a:rPr lang="en-US"/>
               <a:t>Fifth level</a:t>
             </a:r>
-            <a:endParaRPr lang="en-US"/>
           </a:p>
         </p:txBody>
       </p:sp>
@@ -648,7 +1095,7 @@
           <a:p>
             <a:fld id="{5BCAD085-E8A6-8845-BD4E-CB4CCA059FC4}" type="datetimeFigureOut">
               <a:rPr lang="en-US" smtClean="0"/>
-              <a:t>1/27/13</a:t>
+              <a:t>7/13/26</a:t>
             </a:fld>
             <a:endParaRPr lang="en-US"/>
           </a:p>
@@ -742,10 +1189,9 @@
           <a:lstStyle/>
           <a:p>
             <a:r>
-              <a:rPr lang="en-US" smtClean="0"/>
+              <a:rPr lang="en-US"/>
               <a:t>Click to edit Master title style</a:t>
             </a:r>
-            <a:endParaRPr lang="en-US"/>
           </a:p>
         </p:txBody>
       </p:sp>
@@ -766,38 +1212,37 @@
           <a:p>
             <a:pPr lvl="0"/>
             <a:r>
-              <a:rPr lang="en-US" smtClean="0"/>
+              <a:rPr lang="en-US"/>
               <a:t>Click to edit Master text styles</a:t>
             </a:r>
           </a:p>
           <a:p>
             <a:pPr lvl="1"/>
             <a:r>
-              <a:rPr lang="en-US" smtClean="0"/>
+              <a:rPr lang="en-US"/>
               <a:t>Second level</a:t>
             </a:r>
           </a:p>
           <a:p>
             <a:pPr lvl="2"/>
             <a:r>
-              <a:rPr lang="en-US" smtClean="0"/>
+              <a:rPr lang="en-US"/>
               <a:t>Third level</a:t>
             </a:r>
           </a:p>
           <a:p>
             <a:pPr lvl="3"/>
             <a:r>
-              <a:rPr lang="en-US" smtClean="0"/>
+              <a:rPr lang="en-US"/>
               <a:t>Fourth level</a:t>
             </a:r>
           </a:p>
           <a:p>
             <a:pPr lvl="4"/>
             <a:r>
-              <a:rPr lang="en-US" smtClean="0"/>
+              <a:rPr lang="en-US"/>
               <a:t>Fifth level</a:t>
             </a:r>
-            <a:endParaRPr lang="en-US"/>
           </a:p>
         </p:txBody>
       </p:sp>
@@ -818,7 +1263,7 @@
           <a:p>
             <a:fld id="{5BCAD085-E8A6-8845-BD4E-CB4CCA059FC4}" type="datetimeFigureOut">
               <a:rPr lang="en-US" smtClean="0"/>
-              <a:t>1/27/13</a:t>
+              <a:t>7/13/26</a:t>
             </a:fld>
             <a:endParaRPr lang="en-US"/>
           </a:p>
@@ -921,10 +1366,9 @@
           </a:lstStyle>
           <a:p>
             <a:r>
-              <a:rPr lang="en-US" smtClean="0"/>
+              <a:rPr lang="en-US"/>
               <a:t>Click to edit Master title style</a:t>
             </a:r>
-            <a:endParaRPr lang="en-US"/>
           </a:p>
         </p:txBody>
       </p:sp>
@@ -1041,7 +1485,7 @@
           <a:p>
             <a:pPr lvl="0"/>
             <a:r>
-              <a:rPr lang="en-US" smtClean="0"/>
+              <a:rPr lang="en-US"/>
               <a:t>Click to edit Master text styles</a:t>
             </a:r>
           </a:p>
@@ -1064,7 +1508,7 @@
           <a:p>
             <a:fld id="{5BCAD085-E8A6-8845-BD4E-CB4CCA059FC4}" type="datetimeFigureOut">
               <a:rPr lang="en-US" smtClean="0"/>
-              <a:t>1/27/13</a:t>
+              <a:t>7/13/26</a:t>
             </a:fld>
             <a:endParaRPr lang="en-US"/>
           </a:p>
@@ -1158,10 +1602,9 @@
           <a:lstStyle/>
           <a:p>
             <a:r>
-              <a:rPr lang="en-US" smtClean="0"/>
+              <a:rPr lang="en-US"/>
               <a:t>Click to edit Master title style</a:t>
             </a:r>
-            <a:endParaRPr lang="en-US"/>
           </a:p>
         </p:txBody>
       </p:sp>
@@ -1215,38 +1658,37 @@
           <a:p>
             <a:pPr lvl="0"/>
             <a:r>
-              <a:rPr lang="en-US" smtClean="0"/>
+              <a:rPr lang="en-US"/>
               <a:t>Click to edit Master text styles</a:t>
             </a:r>
           </a:p>
           <a:p>
             <a:pPr lvl="1"/>
             <a:r>
-              <a:rPr lang="en-US" smtClean="0"/>
+              <a:rPr lang="en-US"/>
               <a:t>Second level</a:t>
             </a:r>
           </a:p>
           <a:p>
             <a:pPr lvl="2"/>
             <a:r>
-              <a:rPr lang="en-US" smtClean="0"/>
+              <a:rPr lang="en-US"/>
               <a:t>Third level</a:t>
             </a:r>
           </a:p>
           <a:p>
             <a:pPr lvl="3"/>
             <a:r>
-              <a:rPr lang="en-US" smtClean="0"/>
+              <a:rPr lang="en-US"/>
               <a:t>Fourth level</a:t>
             </a:r>
           </a:p>
           <a:p>
             <a:pPr lvl="4"/>
             <a:r>
-              <a:rPr lang="en-US" smtClean="0"/>
+              <a:rPr lang="en-US"/>
               <a:t>Fifth level</a:t>
             </a:r>
-            <a:endParaRPr lang="en-US"/>
           </a:p>
         </p:txBody>
       </p:sp>
@@ -1300,38 +1742,37 @@
           <a:p>
             <a:pPr lvl="0"/>
             <a:r>
-              <a:rPr lang="en-US" smtClean="0"/>
+              <a:rPr lang="en-US"/>
               <a:t>Click to edit Master text styles</a:t>
             </a:r>
           </a:p>
           <a:p>
             <a:pPr lvl="1"/>
             <a:r>
-              <a:rPr lang="en-US" smtClean="0"/>
+              <a:rPr lang="en-US"/>
               <a:t>Second level</a:t>
             </a:r>
           </a:p>
           <a:p>
             <a:pPr lvl="2"/>
             <a:r>
-              <a:rPr lang="en-US" smtClean="0"/>
+              <a:rPr lang="en-US"/>
               <a:t>Third level</a:t>
             </a:r>
           </a:p>
           <a:p>
             <a:pPr lvl="3"/>
             <a:r>
-              <a:rPr lang="en-US" smtClean="0"/>
+              <a:rPr lang="en-US"/>
               <a:t>Fourth level</a:t>
             </a:r>
           </a:p>
           <a:p>
             <a:pPr lvl="4"/>
             <a:r>
-              <a:rPr lang="en-US" smtClean="0"/>
+              <a:rPr lang="en-US"/>
               <a:t>Fifth level</a:t>
             </a:r>
-            <a:endParaRPr lang="en-US"/>
           </a:p>
         </p:txBody>
       </p:sp>
@@ -1352,7 +1793,7 @@
           <a:p>
             <a:fld id="{5BCAD085-E8A6-8845-BD4E-CB4CCA059FC4}" type="datetimeFigureOut">
               <a:rPr lang="en-US" smtClean="0"/>
-              <a:t>1/27/13</a:t>
+              <a:t>7/13/26</a:t>
             </a:fld>
             <a:endParaRPr lang="en-US"/>
           </a:p>
@@ -1450,10 +1891,9 @@
           </a:lstStyle>
           <a:p>
             <a:r>
-              <a:rPr lang="en-US" smtClean="0"/>
+              <a:rPr lang="en-US"/>
               <a:t>Click to edit Master title style</a:t>
             </a:r>
-            <a:endParaRPr lang="en-US"/>
           </a:p>
         </p:txBody>
       </p:sp>
@@ -1516,7 +1956,7 @@
           <a:p>
             <a:pPr lvl="0"/>
             <a:r>
-              <a:rPr lang="en-US" smtClean="0"/>
+              <a:rPr lang="en-US"/>
               <a:t>Click to edit Master text styles</a:t>
             </a:r>
           </a:p>
@@ -1572,38 +2012,37 @@
           <a:p>
             <a:pPr lvl="0"/>
             <a:r>
-              <a:rPr lang="en-US" smtClean="0"/>
+              <a:rPr lang="en-US"/>
               <a:t>Click to edit Master text styles</a:t>
             </a:r>
           </a:p>
           <a:p>
             <a:pPr lvl="1"/>
             <a:r>
-              <a:rPr lang="en-US" smtClean="0"/>
+              <a:rPr lang="en-US"/>
               <a:t>Second level</a:t>
             </a:r>
           </a:p>
           <a:p>
             <a:pPr lvl="2"/>
             <a:r>
-              <a:rPr lang="en-US" smtClean="0"/>
+              <a:rPr lang="en-US"/>
               <a:t>Third level</a:t>
             </a:r>
           </a:p>
           <a:p>
             <a:pPr lvl="3"/>
             <a:r>
-              <a:rPr lang="en-US" smtClean="0"/>
+              <a:rPr lang="en-US"/>
               <a:t>Fourth level</a:t>
             </a:r>
           </a:p>
           <a:p>
             <a:pPr lvl="4"/>
             <a:r>
-              <a:rPr lang="en-US" smtClean="0"/>
+              <a:rPr lang="en-US"/>
               <a:t>Fifth level</a:t>
             </a:r>
-            <a:endParaRPr lang="en-US"/>
           </a:p>
         </p:txBody>
       </p:sp>
@@ -1666,7 +2105,7 @@
           <a:p>
             <a:pPr lvl="0"/>
             <a:r>
-              <a:rPr lang="en-US" smtClean="0"/>
+              <a:rPr lang="en-US"/>
               <a:t>Click to edit Master text styles</a:t>
             </a:r>
           </a:p>
@@ -1722,38 +2161,37 @@
           <a:p>
             <a:pPr lvl="0"/>
             <a:r>
-              <a:rPr lang="en-US" smtClean="0"/>
+              <a:rPr lang="en-US"/>
               <a:t>Click to edit Master text styles</a:t>
             </a:r>
           </a:p>
           <a:p>
             <a:pPr lvl="1"/>
             <a:r>
-              <a:rPr lang="en-US" smtClean="0"/>
+              <a:rPr lang="en-US"/>
               <a:t>Second level</a:t>
             </a:r>
           </a:p>
           <a:p>
             <a:pPr lvl="2"/>
             <a:r>
-              <a:rPr lang="en-US" smtClean="0"/>
+              <a:rPr lang="en-US"/>
               <a:t>Third level</a:t>
             </a:r>
           </a:p>
           <a:p>
             <a:pPr lvl="3"/>
             <a:r>
-              <a:rPr lang="en-US" smtClean="0"/>
+              <a:rPr lang="en-US"/>
               <a:t>Fourth level</a:t>
             </a:r>
           </a:p>
           <a:p>
             <a:pPr lvl="4"/>
             <a:r>
-              <a:rPr lang="en-US" smtClean="0"/>
+              <a:rPr lang="en-US"/>
               <a:t>Fifth level</a:t>
             </a:r>
-            <a:endParaRPr lang="en-US"/>
           </a:p>
         </p:txBody>
       </p:sp>
@@ -1774,7 +2212,7 @@
           <a:p>
             <a:fld id="{5BCAD085-E8A6-8845-BD4E-CB4CCA059FC4}" type="datetimeFigureOut">
               <a:rPr lang="en-US" smtClean="0"/>
-              <a:t>1/27/13</a:t>
+              <a:t>7/13/26</a:t>
             </a:fld>
             <a:endParaRPr lang="en-US"/>
           </a:p>
@@ -1868,10 +2306,9 @@
           <a:lstStyle/>
           <a:p>
             <a:r>
-              <a:rPr lang="en-US" smtClean="0"/>
+              <a:rPr lang="en-US"/>
               <a:t>Click to edit Master title style</a:t>
             </a:r>
-            <a:endParaRPr lang="en-US"/>
           </a:p>
         </p:txBody>
       </p:sp>
@@ -1892,7 +2329,7 @@
           <a:p>
             <a:fld id="{5BCAD085-E8A6-8845-BD4E-CB4CCA059FC4}" type="datetimeFigureOut">
               <a:rPr lang="en-US" smtClean="0"/>
-              <a:t>1/27/13</a:t>
+              <a:t>7/13/26</a:t>
             </a:fld>
             <a:endParaRPr lang="en-US"/>
           </a:p>
@@ -1987,7 +2424,7 @@
           <a:p>
             <a:fld id="{5BCAD085-E8A6-8845-BD4E-CB4CCA059FC4}" type="datetimeFigureOut">
               <a:rPr lang="en-US" smtClean="0"/>
-              <a:t>1/27/13</a:t>
+              <a:t>7/13/26</a:t>
             </a:fld>
             <a:endParaRPr lang="en-US"/>
           </a:p>
@@ -2090,10 +2527,9 @@
           </a:lstStyle>
           <a:p>
             <a:r>
-              <a:rPr lang="en-US" smtClean="0"/>
+              <a:rPr lang="en-US"/>
               <a:t>Click to edit Master title style</a:t>
             </a:r>
-            <a:endParaRPr lang="en-US"/>
           </a:p>
         </p:txBody>
       </p:sp>
@@ -2147,38 +2583,37 @@
           <a:p>
             <a:pPr lvl="0"/>
             <a:r>
-              <a:rPr lang="en-US" smtClean="0"/>
+              <a:rPr lang="en-US"/>
               <a:t>Click to edit Master text styles</a:t>
             </a:r>
           </a:p>
           <a:p>
             <a:pPr lvl="1"/>
             <a:r>
-              <a:rPr lang="en-US" smtClean="0"/>
+              <a:rPr lang="en-US"/>
               <a:t>Second level</a:t>
             </a:r>
           </a:p>
           <a:p>
             <a:pPr lvl="2"/>
             <a:r>
-              <a:rPr lang="en-US" smtClean="0"/>
+              <a:rPr lang="en-US"/>
               <a:t>Third level</a:t>
             </a:r>
           </a:p>
           <a:p>
             <a:pPr lvl="3"/>
             <a:r>
-              <a:rPr lang="en-US" smtClean="0"/>
+              <a:rPr lang="en-US"/>
               <a:t>Fourth level</a:t>
             </a:r>
           </a:p>
           <a:p>
             <a:pPr lvl="4"/>
             <a:r>
-              <a:rPr lang="en-US" smtClean="0"/>
+              <a:rPr lang="en-US"/>
               <a:t>Fifth level</a:t>
             </a:r>
-            <a:endParaRPr lang="en-US"/>
           </a:p>
         </p:txBody>
       </p:sp>
@@ -2241,7 +2676,7 @@
           <a:p>
             <a:pPr lvl="0"/>
             <a:r>
-              <a:rPr lang="en-US" smtClean="0"/>
+              <a:rPr lang="en-US"/>
               <a:t>Click to edit Master text styles</a:t>
             </a:r>
           </a:p>
@@ -2264,7 +2699,7 @@
           <a:p>
             <a:fld id="{5BCAD085-E8A6-8845-BD4E-CB4CCA059FC4}" type="datetimeFigureOut">
               <a:rPr lang="en-US" smtClean="0"/>
-              <a:t>1/27/13</a:t>
+              <a:t>7/13/26</a:t>
             </a:fld>
             <a:endParaRPr lang="en-US"/>
           </a:p>
@@ -2367,10 +2802,9 @@
           </a:lstStyle>
           <a:p>
             <a:r>
-              <a:rPr lang="en-US" smtClean="0"/>
+              <a:rPr lang="en-US"/>
               <a:t>Click to edit Master title style</a:t>
             </a:r>
-            <a:endParaRPr lang="en-US"/>
           </a:p>
         </p:txBody>
       </p:sp>
@@ -2494,7 +2928,7 @@
           <a:p>
             <a:pPr lvl="0"/>
             <a:r>
-              <a:rPr lang="en-US" smtClean="0"/>
+              <a:rPr lang="en-US"/>
               <a:t>Click to edit Master text styles</a:t>
             </a:r>
           </a:p>
@@ -2517,7 +2951,7 @@
           <a:p>
             <a:fld id="{5BCAD085-E8A6-8845-BD4E-CB4CCA059FC4}" type="datetimeFigureOut">
               <a:rPr lang="en-US" smtClean="0"/>
-              <a:t>1/27/13</a:t>
+              <a:t>7/13/26</a:t>
             </a:fld>
             <a:endParaRPr lang="en-US"/>
           </a:p>
@@ -2626,10 +3060,9 @@
           <a:lstStyle/>
           <a:p>
             <a:r>
-              <a:rPr lang="en-US" smtClean="0"/>
+              <a:rPr lang="en-US"/>
               <a:t>Click to edit Master title style</a:t>
             </a:r>
-            <a:endParaRPr lang="en-US"/>
           </a:p>
         </p:txBody>
       </p:sp>
@@ -2660,38 +3093,37 @@
           <a:p>
             <a:pPr lvl="0"/>
             <a:r>
-              <a:rPr lang="en-US" smtClean="0"/>
+              <a:rPr lang="en-US"/>
               <a:t>Click to edit Master text styles</a:t>
             </a:r>
           </a:p>
           <a:p>
             <a:pPr lvl="1"/>
             <a:r>
-              <a:rPr lang="en-US" smtClean="0"/>
+              <a:rPr lang="en-US"/>
               <a:t>Second level</a:t>
             </a:r>
           </a:p>
           <a:p>
             <a:pPr lvl="2"/>
             <a:r>
-              <a:rPr lang="en-US" smtClean="0"/>
+              <a:rPr lang="en-US"/>
               <a:t>Third level</a:t>
             </a:r>
           </a:p>
           <a:p>
             <a:pPr lvl="3"/>
             <a:r>
-              <a:rPr lang="en-US" smtClean="0"/>
+              <a:rPr lang="en-US"/>
               <a:t>Fourth level</a:t>
             </a:r>
           </a:p>
           <a:p>
             <a:pPr lvl="4"/>
             <a:r>
-              <a:rPr lang="en-US" smtClean="0"/>
+              <a:rPr lang="en-US"/>
               <a:t>Fifth level</a:t>
             </a:r>
-            <a:endParaRPr lang="en-US"/>
           </a:p>
         </p:txBody>
       </p:sp>
@@ -2730,7 +3162,7 @@
           <a:p>
             <a:fld id="{5BCAD085-E8A6-8845-BD4E-CB4CCA059FC4}" type="datetimeFigureOut">
               <a:rPr lang="en-US" smtClean="0"/>
-              <a:t>1/27/13</a:t>
+              <a:t>7/13/26</a:t>
             </a:fld>
             <a:endParaRPr lang="en-US"/>
           </a:p>
@@ -3089,7 +3521,7 @@
 </file>
 
 <file path=ppt/slides/slide1.xml><?xml version="1.0" encoding="utf-8"?>
-<p:sld xmlns:a="http://schemas.openxmlformats.org/drawingml/2006/main" xmlns:p="http://schemas.openxmlformats.org/presentationml/2006/main" xmlns:r="http://schemas.openxmlformats.org/officeDocument/2006/relationships">
+<p:sld xmlns:a="http://schemas.openxmlformats.org/drawingml/2006/main" xmlns:r="http://schemas.openxmlformats.org/officeDocument/2006/relationships" xmlns:p="http://schemas.openxmlformats.org/presentationml/2006/main">
   <p:cSld>
     <p:bg>
       <p:bgPr>
@@ -3105,7 +3537,299 @@
         <p:cNvGrpSpPr/>
         <p:nvPr/>
       </p:nvGrpSpPr>
-      <p:grpSpPr/>
+      <p:grpSpPr>
+        <a:xfrm>
+          <a:off x="0" y="0"/>
+          <a:ext cx="0" cy="0"/>
+          <a:chOff x="0" y="0"/>
+          <a:chExt cx="0" cy="0"/>
+        </a:xfrm>
+      </p:grpSpPr>
+      <p:sp>
+        <p:nvSpPr>
+          <p:cNvPr id="4" name="TextBox 3"/>
+          <p:cNvSpPr txBox="1"/>
+          <p:nvPr/>
+        </p:nvSpPr>
+        <p:spPr>
+          <a:xfrm>
+            <a:off x="822960" y="2103120"/>
+            <a:ext cx="10515600" cy="1463040"/>
+          </a:xfrm>
+          <a:prstGeom prst="rect">
+            <a:avLst/>
+          </a:prstGeom>
+          <a:noFill/>
+        </p:spPr>
+        <p:txBody>
+          <a:bodyPr wrap="square">
+            <a:spAutoFit/>
+          </a:bodyPr>
+          <a:lstStyle/>
+          <a:p>
+            <a:r>
+              <a:rPr sz="7600" b="1">
+                <a:solidFill>
+                  <a:srgbClr val="ECEAE4"/>
+                </a:solidFill>
+                <a:latin typeface="Arial"/>
+              </a:rPr>
+              <a:t>CONTXT</a:t>
+            </a:r>
+          </a:p>
+        </p:txBody>
+      </p:sp>
+      <p:sp>
+        <p:nvSpPr>
+          <p:cNvPr id="5" name="TextBox 4"/>
+          <p:cNvSpPr txBox="1"/>
+          <p:nvPr/>
+        </p:nvSpPr>
+        <p:spPr>
+          <a:xfrm>
+            <a:off x="822960" y="3383280"/>
+            <a:ext cx="10515600" cy="914400"/>
+          </a:xfrm>
+          <a:prstGeom prst="rect">
+            <a:avLst/>
+          </a:prstGeom>
+          <a:noFill/>
+        </p:spPr>
+        <p:txBody>
+          <a:bodyPr wrap="square">
+            <a:spAutoFit/>
+          </a:bodyPr>
+          <a:lstStyle/>
+          <a:p>
+            <a:r>
+              <a:rPr sz="3000" b="0">
+                <a:solidFill>
+                  <a:srgbClr val="E0B64D"/>
+                </a:solidFill>
+                <a:latin typeface="Arial"/>
+              </a:rPr>
+              <a:t>One private context layer for every AI.</a:t>
+            </a:r>
+          </a:p>
+        </p:txBody>
+      </p:sp>
+      <p:sp>
+        <p:nvSpPr>
+          <p:cNvPr id="6" name="TextBox 5"/>
+          <p:cNvSpPr txBox="1"/>
+          <p:nvPr/>
+        </p:nvSpPr>
+        <p:spPr>
+          <a:xfrm>
+            <a:off x="822960" y="4297680"/>
+            <a:ext cx="10515600" cy="1463040"/>
+          </a:xfrm>
+          <a:prstGeom prst="rect">
+            <a:avLst/>
+          </a:prstGeom>
+          <a:noFill/>
+        </p:spPr>
+        <p:txBody>
+          <a:bodyPr wrap="square">
+            <a:spAutoFit/>
+          </a:bodyPr>
+          <a:lstStyle/>
+          <a:p>
+            <a:r>
+              <a:rPr sz="1800" b="0">
+                <a:solidFill>
+                  <a:srgbClr val="9A9892"/>
+                </a:solidFill>
+                <a:latin typeface="Arial"/>
+              </a:rPr>
+              <a:t>It remembers you and acts for you across Claude, ChatGPT &amp; Gemini —</a:t>
+            </a:r>
+          </a:p>
+          <a:p>
+            <a:r>
+              <a:rPr sz="1800" b="0">
+                <a:solidFill>
+                  <a:srgbClr val="9A9892"/>
+                </a:solidFill>
+                <a:latin typeface="Arial"/>
+              </a:rPr>
+              <a:t>and your private data never leaves your device.</a:t>
+            </a:r>
+          </a:p>
+        </p:txBody>
+      </p:sp>
+      <p:sp>
+        <p:nvSpPr>
+          <p:cNvPr id="7" name="TextBox 6"/>
+          <p:cNvSpPr txBox="1"/>
+          <p:nvPr/>
+        </p:nvSpPr>
+        <p:spPr>
+          <a:xfrm>
+            <a:off x="822960" y="5852160"/>
+            <a:ext cx="10515600" cy="692497"/>
+          </a:xfrm>
+          <a:prstGeom prst="rect">
+            <a:avLst/>
+          </a:prstGeom>
+          <a:noFill/>
+        </p:spPr>
+        <p:txBody>
+          <a:bodyPr wrap="square">
+            <a:spAutoFit/>
+          </a:bodyPr>
+          <a:lstStyle/>
+          <a:p>
+            <a:r>
+              <a:rPr sz="1300" b="0" dirty="0">
+                <a:solidFill>
+                  <a:srgbClr val="9A9892"/>
+                </a:solidFill>
+                <a:latin typeface="Arial"/>
+              </a:rPr>
+              <a:t>AMD Developer Hackathon ACT II · Track 3 (Unicorn)</a:t>
+            </a:r>
+          </a:p>
+          <a:p>
+            <a:r>
+              <a:rPr lang="en-IN" sz="1300" b="0" dirty="0">
+                <a:solidFill>
+                  <a:srgbClr val="5FB6AD"/>
+                </a:solidFill>
+                <a:latin typeface="Arial"/>
+                <a:hlinkClick r:id="rId3"/>
+              </a:rPr>
+              <a:t>blackx16.github.io/contxt</a:t>
+            </a:r>
+            <a:r>
+              <a:rPr lang="en-IN" sz="1300" b="0" dirty="0">
+                <a:solidFill>
+                  <a:srgbClr val="5FB6AD"/>
+                </a:solidFill>
+                <a:latin typeface="Arial"/>
+              </a:rPr>
+              <a:t> </a:t>
+            </a:r>
+            <a:br>
+              <a:rPr lang="en-IN" sz="1300" b="0" dirty="0">
+                <a:solidFill>
+                  <a:srgbClr val="5FB6AD"/>
+                </a:solidFill>
+                <a:latin typeface="Arial"/>
+              </a:rPr>
+            </a:br>
+            <a:r>
+              <a:rPr lang="en-IN" sz="1300" b="0" dirty="0">
+                <a:solidFill>
+                  <a:srgbClr val="5FB6AD"/>
+                </a:solidFill>
+                <a:latin typeface="Arial"/>
+                <a:hlinkClick r:id="rId4" tooltip="github"/>
+              </a:rPr>
+              <a:t>g</a:t>
+            </a:r>
+            <a:r>
+              <a:rPr sz="1300" b="0" dirty="0" err="1">
+                <a:solidFill>
+                  <a:srgbClr val="5FB6AD"/>
+                </a:solidFill>
+                <a:latin typeface="Arial"/>
+                <a:hlinkClick r:id="rId4" tooltip="github"/>
+              </a:rPr>
+              <a:t>ithub.com</a:t>
+            </a:r>
+            <a:r>
+              <a:rPr sz="1300" b="0" dirty="0">
+                <a:solidFill>
+                  <a:srgbClr val="5FB6AD"/>
+                </a:solidFill>
+                <a:latin typeface="Arial"/>
+                <a:hlinkClick r:id="rId4" tooltip="github"/>
+              </a:rPr>
+              <a:t>/Blackx16/</a:t>
+            </a:r>
+            <a:r>
+              <a:rPr sz="1300" b="0" dirty="0" err="1">
+                <a:solidFill>
+                  <a:srgbClr val="5FB6AD"/>
+                </a:solidFill>
+                <a:latin typeface="Arial"/>
+                <a:hlinkClick r:id="rId4" tooltip="github"/>
+              </a:rPr>
+              <a:t>contxt</a:t>
+            </a:r>
+            <a:endParaRPr sz="1300" b="0" dirty="0">
+              <a:solidFill>
+                <a:srgbClr val="5FB6AD"/>
+              </a:solidFill>
+              <a:latin typeface="Arial"/>
+            </a:endParaRPr>
+          </a:p>
+        </p:txBody>
+      </p:sp>
+      <p:pic>
+        <p:nvPicPr>
+          <p:cNvPr id="10" name="Picture 9" descr="A yellow and black square with a check mark&#10;&#10;AI-generated content may be incorrect.">
+            <a:extLst>
+              <a:ext uri="{FF2B5EF4-FFF2-40B4-BE49-F238E27FC236}">
+                <a16:creationId xmlns:a16="http://schemas.microsoft.com/office/drawing/2014/main" id="{3B127BF1-863C-02A2-6EEB-0769A5AC3223}"/>
+              </a:ext>
+            </a:extLst>
+          </p:cNvPr>
+          <p:cNvPicPr>
+            <a:picLocks noChangeAspect="1"/>
+          </p:cNvPicPr>
+          <p:nvPr/>
+        </p:nvPicPr>
+        <p:blipFill>
+          <a:blip r:embed="rId5"/>
+          <a:stretch>
+            <a:fillRect/>
+          </a:stretch>
+        </p:blipFill>
+        <p:spPr>
+          <a:xfrm>
+            <a:off x="474218" y="194056"/>
+            <a:ext cx="697484" cy="697484"/>
+          </a:xfrm>
+          <a:prstGeom prst="rect">
+            <a:avLst/>
+          </a:prstGeom>
+        </p:spPr>
+      </p:pic>
+    </p:spTree>
+  </p:cSld>
+  <p:clrMapOvr>
+    <a:masterClrMapping/>
+  </p:clrMapOvr>
+</p:sld>
+</file>
+
+<file path=ppt/slides/slide10.xml><?xml version="1.0" encoding="utf-8"?>
+<p:sld xmlns:a="http://schemas.openxmlformats.org/drawingml/2006/main" xmlns:r="http://schemas.openxmlformats.org/officeDocument/2006/relationships" xmlns:p="http://schemas.openxmlformats.org/presentationml/2006/main">
+  <p:cSld>
+    <p:bg>
+      <p:bgPr>
+        <a:solidFill>
+          <a:srgbClr val="0E0E10"/>
+        </a:solidFill>
+        <a:effectLst/>
+      </p:bgPr>
+    </p:bg>
+    <p:spTree>
+      <p:nvGrpSpPr>
+        <p:cNvPr id="1" name=""/>
+        <p:cNvGrpSpPr/>
+        <p:nvPr/>
+      </p:nvGrpSpPr>
+      <p:grpSpPr>
+        <a:xfrm>
+          <a:off x="0" y="0"/>
+          <a:ext cx="0" cy="0"/>
+          <a:chOff x="0" y="0"/>
+          <a:chExt cx="0" cy="0"/>
+        </a:xfrm>
+      </p:grpSpPr>
       <p:sp>
         <p:nvSpPr>
           <p:cNvPr id="2" name="Rectangle 1"/>
@@ -3146,6 +3870,7 @@
           <a:lstStyle/>
           <a:p>
             <a:pPr algn="ctr"/>
+            <a:endParaRPr/>
           </a:p>
         </p:txBody>
       </p:sp>
@@ -3192,8 +3917,8 @@
         </p:nvSpPr>
         <p:spPr>
           <a:xfrm>
-            <a:off x="822960" y="2103120"/>
-            <a:ext cx="10515600" cy="1463040"/>
+            <a:off x="822960" y="914400"/>
+            <a:ext cx="10515600" cy="365760"/>
           </a:xfrm>
           <a:prstGeom prst="rect">
             <a:avLst/>
@@ -3207,13 +3932,13 @@
           <a:lstStyle/>
           <a:p>
             <a:r>
-              <a:rPr sz="7600" b="1">
-                <a:solidFill>
-                  <a:srgbClr val="ECEAE4"/>
-                </a:solidFill>
-                <a:latin typeface="Arial"/>
-              </a:rPr>
-              <a:t>CONTXT</a:t>
+              <a:rPr sz="1300" b="1">
+                <a:solidFill>
+                  <a:srgbClr val="E0B64D"/>
+                </a:solidFill>
+                <a:latin typeface="Arial"/>
+              </a:rPr>
+              <a:t>ON-DEVICE MODEL</a:t>
             </a:r>
           </a:p>
         </p:txBody>
@@ -3226,8 +3951,8 @@
         </p:nvSpPr>
         <p:spPr>
           <a:xfrm>
-            <a:off x="822960" y="3383280"/>
-            <a:ext cx="10515600" cy="914400"/>
+            <a:off x="822960" y="1325880"/>
+            <a:ext cx="10515600" cy="1188720"/>
           </a:xfrm>
           <a:prstGeom prst="rect">
             <a:avLst/>
@@ -3241,13 +3966,13 @@
           <a:lstStyle/>
           <a:p>
             <a:r>
-              <a:rPr sz="3000" b="0">
-                <a:solidFill>
-                  <a:srgbClr val="E0B64D"/>
-                </a:solidFill>
-                <a:latin typeface="Arial"/>
-              </a:rPr>
-              <a:t>One private context layer for every AI.</a:t>
+              <a:rPr sz="3400" b="1">
+                <a:solidFill>
+                  <a:srgbClr val="ECEAE4"/>
+                </a:solidFill>
+                <a:latin typeface="Arial"/>
+              </a:rPr>
+              <a:t>A fine-tuned Gemma gateway — trained, benchmarked, shipped.</a:t>
             </a:r>
           </a:p>
         </p:txBody>
@@ -3260,8 +3985,8 @@
         </p:nvSpPr>
         <p:spPr>
           <a:xfrm>
-            <a:off x="822960" y="4297680"/>
-            <a:ext cx="10515600" cy="1463040"/>
+            <a:off x="822960" y="2651760"/>
+            <a:ext cx="10515600" cy="3123932"/>
           </a:xfrm>
           <a:prstGeom prst="rect">
             <a:avLst/>
@@ -3274,26 +3999,241 @@
           </a:bodyPr>
           <a:lstStyle/>
           <a:p>
-            <a:r>
-              <a:rPr sz="1800" b="0">
-                <a:solidFill>
-                  <a:srgbClr val="9A9892"/>
-                </a:solidFill>
-                <a:latin typeface="Arial"/>
-              </a:rPr>
-              <a:t>It remembers you and acts for you across Claude, ChatGPT &amp; Gemini —</a:t>
-            </a:r>
-          </a:p>
-          <a:p>
-            <a:r>
-              <a:rPr sz="1800" b="0">
-                <a:solidFill>
-                  <a:srgbClr val="9A9892"/>
-                </a:solidFill>
-                <a:latin typeface="Arial"/>
-              </a:rPr>
-              <a:t>and your private data never leaves your device.</a:t>
-            </a:r>
+            <a:pPr>
+              <a:spcAft>
+                <a:spcPts val="1400"/>
+              </a:spcAft>
+            </a:pPr>
+            <a:r>
+              <a:rPr sz="1800" b="1" dirty="0">
+                <a:solidFill>
+                  <a:srgbClr val="E0B64D"/>
+                </a:solidFill>
+                <a:latin typeface="Arial"/>
+              </a:rPr>
+              <a:t>— </a:t>
+            </a:r>
+            <a:r>
+              <a:rPr sz="1800" b="1" dirty="0">
+                <a:solidFill>
+                  <a:srgbClr val="ECEAE4"/>
+                </a:solidFill>
+                <a:latin typeface="Arial"/>
+              </a:rPr>
+              <a:t>Custom-tuned.</a:t>
+            </a:r>
+            <a:r>
+              <a:rPr sz="1800" b="0" dirty="0">
+                <a:solidFill>
+                  <a:srgbClr val="CFCDC7"/>
+                </a:solidFill>
+                <a:latin typeface="Arial"/>
+              </a:rPr>
+              <a:t>  Gemma 3 270M fine-tuned to emit the tier JSON → ONNX q4f16 (WASM), live on Hugging Face: chandr1601/contxt-gateway-270m-onnx.</a:t>
+            </a:r>
+          </a:p>
+          <a:p>
+            <a:pPr>
+              <a:spcAft>
+                <a:spcPts val="1400"/>
+              </a:spcAft>
+            </a:pPr>
+            <a:r>
+              <a:rPr sz="1800" b="1" dirty="0">
+                <a:solidFill>
+                  <a:srgbClr val="E0B64D"/>
+                </a:solidFill>
+                <a:latin typeface="Arial"/>
+              </a:rPr>
+              <a:t>— </a:t>
+            </a:r>
+            <a:r>
+              <a:rPr sz="1800" b="1" dirty="0">
+                <a:solidFill>
+                  <a:srgbClr val="ECEAE4"/>
+                </a:solidFill>
+                <a:latin typeface="Arial"/>
+              </a:rPr>
+              <a:t>Beats base decisively.</a:t>
+            </a:r>
+            <a:r>
+              <a:rPr sz="1800" b="0" dirty="0">
+                <a:solidFill>
+                  <a:srgbClr val="CFCDC7"/>
+                </a:solidFill>
+                <a:latin typeface="Arial"/>
+              </a:rPr>
+              <a:t>  253 hold-out rows: JSON-valid 100% (vs 79%), tier-accuracy 97.6% (vs 43%), PRIVATE recall 99.4% (vs 69%) — cleared the 0.98 ship gate.</a:t>
+            </a:r>
+          </a:p>
+          <a:p>
+            <a:pPr>
+              <a:spcAft>
+                <a:spcPts val="1400"/>
+              </a:spcAft>
+            </a:pPr>
+            <a:r>
+              <a:rPr sz="1800" b="1" dirty="0">
+                <a:solidFill>
+                  <a:srgbClr val="E0B64D"/>
+                </a:solidFill>
+                <a:latin typeface="Arial"/>
+              </a:rPr>
+              <a:t>— </a:t>
+            </a:r>
+            <a:r>
+              <a:rPr sz="1800" b="1" dirty="0">
+                <a:solidFill>
+                  <a:srgbClr val="ECEAE4"/>
+                </a:solidFill>
+                <a:latin typeface="Arial"/>
+              </a:rPr>
+              <a:t>See the work.</a:t>
+            </a:r>
+            <a:r>
+              <a:rPr sz="1800" b="0" dirty="0">
+                <a:solidFill>
+                  <a:srgbClr val="CFCDC7"/>
+                </a:solidFill>
+                <a:latin typeface="Arial"/>
+              </a:rPr>
+              <a:t>  1,438-row dataset, training code &amp; the prompt contract in finetune/ (branch finetune/gemma-gateway-270m).</a:t>
+            </a:r>
+            <a:endParaRPr lang="en-US" sz="1800" b="0" dirty="0">
+              <a:solidFill>
+                <a:srgbClr val="CFCDC7"/>
+              </a:solidFill>
+              <a:latin typeface="Arial"/>
+            </a:endParaRPr>
+          </a:p>
+          <a:p>
+            <a:pPr>
+              <a:spcAft>
+                <a:spcPts val="1400"/>
+              </a:spcAft>
+            </a:pPr>
+            <a:r>
+              <a:rPr lang="en-IN" b="1" dirty="0">
+                <a:solidFill>
+                  <a:srgbClr val="E0B64D"/>
+                </a:solidFill>
+                <a:latin typeface="Arial"/>
+              </a:rPr>
+              <a:t>— </a:t>
+            </a:r>
+            <a:r>
+              <a:rPr lang="en-IN" dirty="0">
+                <a:solidFill>
+                  <a:schemeClr val="bg1">
+                    <a:lumMod val="75000"/>
+                  </a:schemeClr>
+                </a:solidFill>
+                <a:latin typeface="Arial" panose="020B0604020202020204" pitchFamily="34" charset="0"/>
+                <a:cs typeface="Arial" panose="020B0604020202020204" pitchFamily="34" charset="0"/>
+              </a:rPr>
+              <a:t>Our on-device gateway classifier was </a:t>
+            </a:r>
+            <a:r>
+              <a:rPr lang="en-IN" b="1" dirty="0">
+                <a:solidFill>
+                  <a:schemeClr val="bg1"/>
+                </a:solidFill>
+                <a:latin typeface="Arial" panose="020B0604020202020204" pitchFamily="34" charset="0"/>
+                <a:cs typeface="Arial" panose="020B0604020202020204" pitchFamily="34" charset="0"/>
+              </a:rPr>
+              <a:t>fine-tuned on</a:t>
+            </a:r>
+            <a:r>
+              <a:rPr lang="en-IN" dirty="0">
+                <a:solidFill>
+                  <a:schemeClr val="bg1">
+                    <a:lumMod val="75000"/>
+                  </a:schemeClr>
+                </a:solidFill>
+                <a:latin typeface="Arial" panose="020B0604020202020204" pitchFamily="34" charset="0"/>
+                <a:cs typeface="Arial" panose="020B0604020202020204" pitchFamily="34" charset="0"/>
+              </a:rPr>
+              <a:t> an </a:t>
+            </a:r>
+            <a:r>
+              <a:rPr lang="en-IN" b="1" dirty="0">
+                <a:solidFill>
+                  <a:schemeClr val="bg1"/>
+                </a:solidFill>
+                <a:latin typeface="Arial" panose="020B0604020202020204" pitchFamily="34" charset="0"/>
+                <a:cs typeface="Arial" panose="020B0604020202020204" pitchFamily="34" charset="0"/>
+              </a:rPr>
+              <a:t>AMD Instinct MI300X </a:t>
+            </a:r>
+            <a:r>
+              <a:rPr lang="en-IN" dirty="0">
+                <a:solidFill>
+                  <a:schemeClr val="bg1">
+                    <a:lumMod val="75000"/>
+                  </a:schemeClr>
+                </a:solidFill>
+                <a:latin typeface="Arial" panose="020B0604020202020204" pitchFamily="34" charset="0"/>
+                <a:cs typeface="Arial" panose="020B0604020202020204" pitchFamily="34" charset="0"/>
+              </a:rPr>
+              <a:t>(</a:t>
+            </a:r>
+            <a:r>
+              <a:rPr lang="en-IN" dirty="0" err="1">
+                <a:solidFill>
+                  <a:schemeClr val="bg1">
+                    <a:lumMod val="75000"/>
+                  </a:schemeClr>
+                </a:solidFill>
+                <a:latin typeface="Arial" panose="020B0604020202020204" pitchFamily="34" charset="0"/>
+                <a:cs typeface="Arial" panose="020B0604020202020204" pitchFamily="34" charset="0"/>
+              </a:rPr>
+              <a:t>ROCm</a:t>
+            </a:r>
+            <a:r>
+              <a:rPr lang="en-IN" dirty="0">
+                <a:solidFill>
+                  <a:schemeClr val="bg1">
+                    <a:lumMod val="75000"/>
+                  </a:schemeClr>
+                </a:solidFill>
+                <a:latin typeface="Arial" panose="020B0604020202020204" pitchFamily="34" charset="0"/>
+                <a:cs typeface="Arial" panose="020B0604020202020204" pitchFamily="34" charset="0"/>
+              </a:rPr>
+              <a:t> 7.2, </a:t>
+            </a:r>
+            <a:r>
+              <a:rPr lang="en-IN" dirty="0" err="1">
+                <a:solidFill>
+                  <a:schemeClr val="bg1">
+                    <a:lumMod val="75000"/>
+                  </a:schemeClr>
+                </a:solidFill>
+                <a:latin typeface="Arial" panose="020B0604020202020204" pitchFamily="34" charset="0"/>
+                <a:cs typeface="Arial" panose="020B0604020202020204" pitchFamily="34" charset="0"/>
+              </a:rPr>
+              <a:t>PyTorch</a:t>
+            </a:r>
+            <a:r>
+              <a:rPr lang="en-IN" dirty="0">
+                <a:solidFill>
+                  <a:schemeClr val="bg1">
+                    <a:lumMod val="75000"/>
+                  </a:schemeClr>
+                </a:solidFill>
+                <a:latin typeface="Arial" panose="020B0604020202020204" pitchFamily="34" charset="0"/>
+                <a:cs typeface="Arial" panose="020B0604020202020204" pitchFamily="34" charset="0"/>
+              </a:rPr>
+              <a:t> 2.9). Same accuracy as the Gemma model, 18× lower latency, 6× smaller — AMD trains it, the user's browser runs it, the cloud never sees private data."</a:t>
+            </a:r>
+            <a:endParaRPr sz="1800" dirty="0">
+              <a:solidFill>
+                <a:schemeClr val="bg1">
+                  <a:lumMod val="75000"/>
+                </a:schemeClr>
+              </a:solidFill>
+              <a:latin typeface="Arial" panose="020B0604020202020204" pitchFamily="34" charset="0"/>
+              <a:cs typeface="Arial" panose="020B0604020202020204" pitchFamily="34" charset="0"/>
+            </a:endParaRPr>
           </a:p>
         </p:txBody>
       </p:sp>
@@ -3305,8 +4245,8 @@
         </p:nvSpPr>
         <p:spPr>
           <a:xfrm>
-            <a:off x="822960" y="5852160"/>
-            <a:ext cx="10515600" cy="731520"/>
+            <a:off x="822960" y="6355080"/>
+            <a:ext cx="10515600" cy="365760"/>
           </a:xfrm>
           <a:prstGeom prst="rect">
             <a:avLst/>
@@ -3320,28 +4260,82 @@
           <a:lstStyle/>
           <a:p>
             <a:r>
-              <a:rPr sz="1300" b="0">
+              <a:rPr sz="1000" b="1">
                 <a:solidFill>
                   <a:srgbClr val="9A9892"/>
                 </a:solidFill>
                 <a:latin typeface="Arial"/>
               </a:rPr>
-              <a:t>AMD Developer Hackathon ACT II · Track 3 (Unicorn)</a:t>
-            </a:r>
-          </a:p>
-          <a:p>
-            <a:r>
-              <a:rPr sz="1300" b="0">
-                <a:solidFill>
-                  <a:srgbClr val="5FB6AD"/>
-                </a:solidFill>
-                <a:latin typeface="Arial"/>
-              </a:rPr>
-              <a:t>blackx16.github.io/contxt  ·  github.com/Blackx16/contxt</a:t>
-            </a:r>
-          </a:p>
-        </p:txBody>
-      </p:sp>
+              <a:t>CONTXT</a:t>
+            </a:r>
+          </a:p>
+        </p:txBody>
+      </p:sp>
+      <p:sp>
+        <p:nvSpPr>
+          <p:cNvPr id="8" name="TextBox 7"/>
+          <p:cNvSpPr txBox="1"/>
+          <p:nvPr/>
+        </p:nvSpPr>
+        <p:spPr>
+          <a:xfrm>
+            <a:off x="10789920" y="6355080"/>
+            <a:ext cx="1097280" cy="365760"/>
+          </a:xfrm>
+          <a:prstGeom prst="rect">
+            <a:avLst/>
+          </a:prstGeom>
+          <a:noFill/>
+        </p:spPr>
+        <p:txBody>
+          <a:bodyPr wrap="square">
+            <a:spAutoFit/>
+          </a:bodyPr>
+          <a:lstStyle/>
+          <a:p>
+            <a:pPr algn="r"/>
+            <a:r>
+              <a:rPr sz="1000" b="0">
+                <a:solidFill>
+                  <a:srgbClr val="9A9892"/>
+                </a:solidFill>
+                <a:latin typeface="Arial"/>
+              </a:rPr>
+              <a:t>10</a:t>
+            </a:r>
+          </a:p>
+        </p:txBody>
+      </p:sp>
+      <p:pic>
+        <p:nvPicPr>
+          <p:cNvPr id="9" name="Picture 8" descr="A yellow and black square with a check mark&#10;&#10;AI-generated content may be incorrect.">
+            <a:extLst>
+              <a:ext uri="{FF2B5EF4-FFF2-40B4-BE49-F238E27FC236}">
+                <a16:creationId xmlns:a16="http://schemas.microsoft.com/office/drawing/2014/main" id="{5DBF40EE-6B20-14A0-C43B-657AEC429750}"/>
+              </a:ext>
+            </a:extLst>
+          </p:cNvPr>
+          <p:cNvPicPr>
+            <a:picLocks noChangeAspect="1"/>
+          </p:cNvPicPr>
+          <p:nvPr/>
+        </p:nvPicPr>
+        <p:blipFill>
+          <a:blip r:embed="rId2"/>
+          <a:stretch>
+            <a:fillRect/>
+          </a:stretch>
+        </p:blipFill>
+        <p:spPr>
+          <a:xfrm>
+            <a:off x="474218" y="194056"/>
+            <a:ext cx="697484" cy="697484"/>
+          </a:xfrm>
+          <a:prstGeom prst="rect">
+            <a:avLst/>
+          </a:prstGeom>
+        </p:spPr>
+      </p:pic>
     </p:spTree>
   </p:cSld>
   <p:clrMapOvr>
@@ -3350,8 +4344,8 @@
 </p:sld>
 </file>
 
-<file path=ppt/slides/slide10.xml><?xml version="1.0" encoding="utf-8"?>
-<p:sld xmlns:a="http://schemas.openxmlformats.org/drawingml/2006/main" xmlns:p="http://schemas.openxmlformats.org/presentationml/2006/main" xmlns:r="http://schemas.openxmlformats.org/officeDocument/2006/relationships">
+<file path=ppt/slides/slide11.xml><?xml version="1.0" encoding="utf-8"?>
+<p:sld xmlns:a="http://schemas.openxmlformats.org/drawingml/2006/main" xmlns:r="http://schemas.openxmlformats.org/officeDocument/2006/relationships" xmlns:p="http://schemas.openxmlformats.org/presentationml/2006/main">
   <p:cSld>
     <p:bg>
       <p:bgPr>
@@ -3367,7 +4361,14 @@
         <p:cNvGrpSpPr/>
         <p:nvPr/>
       </p:nvGrpSpPr>
-      <p:grpSpPr/>
+      <p:grpSpPr>
+        <a:xfrm>
+          <a:off x="0" y="0"/>
+          <a:ext cx="0" cy="0"/>
+          <a:chOff x="0" y="0"/>
+          <a:chExt cx="0" cy="0"/>
+        </a:xfrm>
+      </p:grpSpPr>
       <p:sp>
         <p:nvSpPr>
           <p:cNvPr id="2" name="Rectangle 1"/>
@@ -3408,6 +4409,7 @@
           <a:lstStyle/>
           <a:p>
             <a:pPr algn="ctr"/>
+            <a:endParaRPr/>
           </a:p>
         </p:txBody>
       </p:sp>
@@ -3475,7 +4477,7 @@
                 </a:solidFill>
                 <a:latin typeface="Arial"/>
               </a:rPr>
-              <a:t>ON-DEVICE MODEL</a:t>
+              <a:t>ROADMAP</a:t>
             </a:r>
           </a:p>
         </p:txBody>
@@ -3509,7 +4511,7 @@
                 </a:solidFill>
                 <a:latin typeface="Arial"/>
               </a:rPr>
-              <a:t>A fine-tuned Gemma gateway — trained, benchmarked, shipped.</a:t>
+              <a:t>One context layer. Every AI. Your data stays yours.</a:t>
             </a:r>
           </a:p>
         </p:txBody>
@@ -3557,7 +4559,7 @@
                 </a:solidFill>
                 <a:latin typeface="Arial"/>
               </a:rPr>
-              <a:t>Custom-tuned.</a:t>
+              <a:t>Today.</a:t>
             </a:r>
             <a:r>
               <a:rPr sz="1800" b="0">
@@ -3566,7 +4568,7 @@
                 </a:solidFill>
                 <a:latin typeface="Arial"/>
               </a:rPr>
-              <a:t>  Gemma 3 270M fine-tuned to emit the tier JSON → ONNX q4f16 (WASM), live on Hugging Face: chandr1601/contxt-gateway-270m-onnx.</a:t>
+              <a:t>  Web + extension, live injection across Claude / ChatGPT / Gemini.</a:t>
             </a:r>
           </a:p>
           <a:p>
@@ -3591,7 +4593,7 @@
                 </a:solidFill>
                 <a:latin typeface="Arial"/>
               </a:rPr>
-              <a:t>Beats base decisively.</a:t>
+              <a:t>Next.</a:t>
             </a:r>
             <a:r>
               <a:rPr sz="1800" b="0">
@@ -3600,7 +4602,7 @@
                 </a:solidFill>
                 <a:latin typeface="Arial"/>
               </a:rPr>
-              <a:t>  253 hold-out rows: JSON-valid 100% (vs 79%), tier-accuracy 97.6% (vs 43%), PRIVATE recall 99.4% (vs 69%) — cleared the 0.98 ship gate.</a:t>
+              <a:t>  Fully-local mobile (Gemma 3n on-device), Signal-grade multi-device sync.</a:t>
             </a:r>
           </a:p>
           <a:p>
@@ -3625,7 +4627,7 @@
                 </a:solidFill>
                 <a:latin typeface="Arial"/>
               </a:rPr>
-              <a:t>See the work.</a:t>
+              <a:t>Try it.</a:t>
             </a:r>
             <a:r>
               <a:rPr sz="1800" b="0">
@@ -3634,7 +4636,7 @@
                 </a:solidFill>
                 <a:latin typeface="Arial"/>
               </a:rPr>
-              <a:t>  1,438-row dataset, training code &amp; the prompt contract in finetune/ (branch finetune/gemma-gateway-270m).</a:t>
+              <a:t>  blackx16.github.io/contxt · github.com/Blackx16/contxt · ghcr.io/blackx16/contxt</a:t>
             </a:r>
           </a:p>
         </p:txBody>
@@ -3703,11 +4705,41 @@
                 </a:solidFill>
                 <a:latin typeface="Arial"/>
               </a:rPr>
-              <a:t>10</a:t>
-            </a:r>
-          </a:p>
-        </p:txBody>
-      </p:sp>
+              <a:t>11</a:t>
+            </a:r>
+          </a:p>
+        </p:txBody>
+      </p:sp>
+      <p:pic>
+        <p:nvPicPr>
+          <p:cNvPr id="9" name="Picture 8" descr="A yellow and black square with a check mark&#10;&#10;AI-generated content may be incorrect.">
+            <a:extLst>
+              <a:ext uri="{FF2B5EF4-FFF2-40B4-BE49-F238E27FC236}">
+                <a16:creationId xmlns:a16="http://schemas.microsoft.com/office/drawing/2014/main" id="{86076DAE-A182-49E4-5484-F1AC83424E5A}"/>
+              </a:ext>
+            </a:extLst>
+          </p:cNvPr>
+          <p:cNvPicPr>
+            <a:picLocks noChangeAspect="1"/>
+          </p:cNvPicPr>
+          <p:nvPr/>
+        </p:nvPicPr>
+        <p:blipFill>
+          <a:blip r:embed="rId2"/>
+          <a:stretch>
+            <a:fillRect/>
+          </a:stretch>
+        </p:blipFill>
+        <p:spPr>
+          <a:xfrm>
+            <a:off x="474218" y="194056"/>
+            <a:ext cx="697484" cy="697484"/>
+          </a:xfrm>
+          <a:prstGeom prst="rect">
+            <a:avLst/>
+          </a:prstGeom>
+        </p:spPr>
+      </p:pic>
     </p:spTree>
   </p:cSld>
   <p:clrMapOvr>
@@ -3716,8 +4748,8 @@
 </p:sld>
 </file>
 
-<file path=ppt/slides/slide11.xml><?xml version="1.0" encoding="utf-8"?>
-<p:sld xmlns:a="http://schemas.openxmlformats.org/drawingml/2006/main" xmlns:p="http://schemas.openxmlformats.org/presentationml/2006/main" xmlns:r="http://schemas.openxmlformats.org/officeDocument/2006/relationships">
+<file path=ppt/slides/slide2.xml><?xml version="1.0" encoding="utf-8"?>
+<p:sld xmlns:a="http://schemas.openxmlformats.org/drawingml/2006/main" xmlns:r="http://schemas.openxmlformats.org/officeDocument/2006/relationships" xmlns:p="http://schemas.openxmlformats.org/presentationml/2006/main">
   <p:cSld>
     <p:bg>
       <p:bgPr>
@@ -3733,7 +4765,14 @@
         <p:cNvGrpSpPr/>
         <p:nvPr/>
       </p:nvGrpSpPr>
-      <p:grpSpPr/>
+      <p:grpSpPr>
+        <a:xfrm>
+          <a:off x="0" y="0"/>
+          <a:ext cx="0" cy="0"/>
+          <a:chOff x="0" y="0"/>
+          <a:chExt cx="0" cy="0"/>
+        </a:xfrm>
+      </p:grpSpPr>
       <p:sp>
         <p:nvSpPr>
           <p:cNvPr id="2" name="Rectangle 1"/>
@@ -3774,6 +4813,7 @@
           <a:lstStyle/>
           <a:p>
             <a:pPr algn="ctr"/>
+            <a:endParaRPr/>
           </a:p>
         </p:txBody>
       </p:sp>
@@ -3841,7 +4881,7 @@
                 </a:solidFill>
                 <a:latin typeface="Arial"/>
               </a:rPr>
-              <a:t>ROADMAP</a:t>
+              <a:t>THE PROBLEM</a:t>
             </a:r>
           </a:p>
         </p:txBody>
@@ -3875,7 +4915,7 @@
                 </a:solidFill>
                 <a:latin typeface="Arial"/>
               </a:rPr>
-              <a:t>One context layer. Every AI. Your data stays yours.</a:t>
+              <a:t>Every AI grew a memory. None of them share it.</a:t>
             </a:r>
           </a:p>
         </p:txBody>
@@ -3923,7 +4963,7 @@
                 </a:solidFill>
                 <a:latin typeface="Arial"/>
               </a:rPr>
-              <a:t>Today.</a:t>
+              <a:t>Five walled gardens.</a:t>
             </a:r>
             <a:r>
               <a:rPr sz="1800" b="0">
@@ -3932,7 +4972,7 @@
                 </a:solidFill>
                 <a:latin typeface="Arial"/>
               </a:rPr>
-              <a:t>  Web + extension, live injection across Claude / ChatGPT / Gemini.</a:t>
+              <a:t>  ChatGPT, Claude, Gemini, Copilot, Grok — each remembers you separately.</a:t>
             </a:r>
           </a:p>
           <a:p>
@@ -3957,7 +4997,7 @@
                 </a:solidFill>
                 <a:latin typeface="Arial"/>
               </a:rPr>
-              <a:t>Next.</a:t>
+              <a:t>You repeat yourself.</a:t>
             </a:r>
             <a:r>
               <a:rPr sz="1800" b="0">
@@ -3966,7 +5006,7 @@
                 </a:solidFill>
                 <a:latin typeface="Arial"/>
               </a:rPr>
-              <a:t>  Fully-local mobile (Gemma 3n on-device), Signal-grade multi-device sync.</a:t>
+              <a:t>  Re-introducing who you are, what you're building, every time you switch.</a:t>
             </a:r>
           </a:p>
           <a:p>
@@ -3991,7 +5031,7 @@
                 </a:solidFill>
                 <a:latin typeface="Arial"/>
               </a:rPr>
-              <a:t>Try it.</a:t>
+              <a:t>The memory startups</a:t>
             </a:r>
             <a:r>
               <a:rPr sz="1800" b="0">
@@ -4000,7 +5040,7 @@
                 </a:solidFill>
                 <a:latin typeface="Arial"/>
               </a:rPr>
-              <a:t>  blackx16.github.io/contxt · github.com/Blackx16/contxt · ghcr.io/blackx16/contxt</a:t>
+              <a:t>  (Mem0, Supermemory, Letta) are cloud-first and built for developers, not you.</a:t>
             </a:r>
           </a:p>
         </p:txBody>
@@ -4069,11 +5109,41 @@
                 </a:solidFill>
                 <a:latin typeface="Arial"/>
               </a:rPr>
-              <a:t>11</a:t>
-            </a:r>
-          </a:p>
-        </p:txBody>
-      </p:sp>
+              <a:t>2</a:t>
+            </a:r>
+          </a:p>
+        </p:txBody>
+      </p:sp>
+      <p:pic>
+        <p:nvPicPr>
+          <p:cNvPr id="9" name="Picture 8" descr="A yellow and black square with a check mark&#10;&#10;AI-generated content may be incorrect.">
+            <a:extLst>
+              <a:ext uri="{FF2B5EF4-FFF2-40B4-BE49-F238E27FC236}">
+                <a16:creationId xmlns:a16="http://schemas.microsoft.com/office/drawing/2014/main" id="{C2FB65F8-4113-F13C-9B30-A4CAAC8E64E6}"/>
+              </a:ext>
+            </a:extLst>
+          </p:cNvPr>
+          <p:cNvPicPr>
+            <a:picLocks noChangeAspect="1"/>
+          </p:cNvPicPr>
+          <p:nvPr/>
+        </p:nvPicPr>
+        <p:blipFill>
+          <a:blip r:embed="rId2"/>
+          <a:stretch>
+            <a:fillRect/>
+          </a:stretch>
+        </p:blipFill>
+        <p:spPr>
+          <a:xfrm>
+            <a:off x="474218" y="194056"/>
+            <a:ext cx="697484" cy="697484"/>
+          </a:xfrm>
+          <a:prstGeom prst="rect">
+            <a:avLst/>
+          </a:prstGeom>
+        </p:spPr>
+      </p:pic>
     </p:spTree>
   </p:cSld>
   <p:clrMapOvr>
@@ -4082,8 +5152,8 @@
 </p:sld>
 </file>
 
-<file path=ppt/slides/slide2.xml><?xml version="1.0" encoding="utf-8"?>
-<p:sld xmlns:a="http://schemas.openxmlformats.org/drawingml/2006/main" xmlns:p="http://schemas.openxmlformats.org/presentationml/2006/main" xmlns:r="http://schemas.openxmlformats.org/officeDocument/2006/relationships">
+<file path=ppt/slides/slide3.xml><?xml version="1.0" encoding="utf-8"?>
+<p:sld xmlns:a="http://schemas.openxmlformats.org/drawingml/2006/main" xmlns:r="http://schemas.openxmlformats.org/officeDocument/2006/relationships" xmlns:p="http://schemas.openxmlformats.org/presentationml/2006/main">
   <p:cSld>
     <p:bg>
       <p:bgPr>
@@ -4099,7 +5169,14 @@
         <p:cNvGrpSpPr/>
         <p:nvPr/>
       </p:nvGrpSpPr>
-      <p:grpSpPr/>
+      <p:grpSpPr>
+        <a:xfrm>
+          <a:off x="0" y="0"/>
+          <a:ext cx="0" cy="0"/>
+          <a:chOff x="0" y="0"/>
+          <a:chExt cx="0" cy="0"/>
+        </a:xfrm>
+      </p:grpSpPr>
       <p:sp>
         <p:nvSpPr>
           <p:cNvPr id="2" name="Rectangle 1"/>
@@ -4140,6 +5217,7 @@
           <a:lstStyle/>
           <a:p>
             <a:pPr algn="ctr"/>
+            <a:endParaRPr/>
           </a:p>
         </p:txBody>
       </p:sp>
@@ -4203,11 +5281,11 @@
             <a:r>
               <a:rPr sz="1300" b="1">
                 <a:solidFill>
-                  <a:srgbClr val="E0B64D"/>
-                </a:solidFill>
-                <a:latin typeface="Arial"/>
-              </a:rPr>
-              <a:t>THE PROBLEM</a:t>
+                  <a:srgbClr val="5FB6AD"/>
+                </a:solidFill>
+                <a:latin typeface="Arial"/>
+              </a:rPr>
+              <a:t>THE SOLUTION</a:t>
             </a:r>
           </a:p>
         </p:txBody>
@@ -4241,7 +5319,7 @@
                 </a:solidFill>
                 <a:latin typeface="Arial"/>
               </a:rPr>
-              <a:t>Every AI grew a memory. None of them share it.</a:t>
+              <a:t>Your context, everywhere — and it stays yours.</a:t>
             </a:r>
           </a:p>
         </p:txBody>
@@ -4276,7 +5354,7 @@
             <a:r>
               <a:rPr sz="1800" b="1">
                 <a:solidFill>
-                  <a:srgbClr val="E0B64D"/>
+                  <a:srgbClr val="5FB6AD"/>
                 </a:solidFill>
                 <a:latin typeface="Arial"/>
               </a:rPr>
@@ -4289,7 +5367,7 @@
                 </a:solidFill>
                 <a:latin typeface="Arial"/>
               </a:rPr>
-              <a:t>Five walled gardens.</a:t>
+              <a:t>Portable.</a:t>
             </a:r>
             <a:r>
               <a:rPr sz="1800" b="0">
@@ -4298,7 +5376,7 @@
                 </a:solidFill>
                 <a:latin typeface="Arial"/>
               </a:rPr>
-              <a:t>  ChatGPT, Claude, Gemini, Copilot, Grok — each remembers you separately.</a:t>
+              <a:t>  One context layer that works across every AI, not locked inside one.</a:t>
             </a:r>
           </a:p>
           <a:p>
@@ -4310,7 +5388,7 @@
             <a:r>
               <a:rPr sz="1800" b="1">
                 <a:solidFill>
-                  <a:srgbClr val="E0B64D"/>
+                  <a:srgbClr val="5FB6AD"/>
                 </a:solidFill>
                 <a:latin typeface="Arial"/>
               </a:rPr>
@@ -4323,7 +5401,7 @@
                 </a:solidFill>
                 <a:latin typeface="Arial"/>
               </a:rPr>
-              <a:t>You repeat yourself.</a:t>
+              <a:t>Private by default.</a:t>
             </a:r>
             <a:r>
               <a:rPr sz="1800" b="0">
@@ -4332,7 +5410,7 @@
                 </a:solidFill>
                 <a:latin typeface="Arial"/>
               </a:rPr>
-              <a:t>  Re-introducing who you are, what you're building, every time you switch.</a:t>
+              <a:t>  A Crown-Jewels Gateway keeps sensitive context on your device.</a:t>
             </a:r>
           </a:p>
           <a:p>
@@ -4344,7 +5422,7 @@
             <a:r>
               <a:rPr sz="1800" b="1">
                 <a:solidFill>
-                  <a:srgbClr val="E0B64D"/>
+                  <a:srgbClr val="5FB6AD"/>
                 </a:solidFill>
                 <a:latin typeface="Arial"/>
               </a:rPr>
@@ -4357,7 +5435,7 @@
                 </a:solidFill>
                 <a:latin typeface="Arial"/>
               </a:rPr>
-              <a:t>The memory startups</a:t>
+              <a:t>Consumer-first.</a:t>
             </a:r>
             <a:r>
               <a:rPr sz="1800" b="0">
@@ -4366,7 +5444,7 @@
                 </a:solidFill>
                 <a:latin typeface="Arial"/>
               </a:rPr>
-              <a:t>  (Mem0, Supermemory, Letta) are cloud-first and built for developers, not you.</a:t>
+              <a:t>  The piece nobody built: memory that follows you and protects you.</a:t>
             </a:r>
           </a:p>
         </p:txBody>
@@ -4435,11 +5513,41 @@
                 </a:solidFill>
                 <a:latin typeface="Arial"/>
               </a:rPr>
-              <a:t>2</a:t>
-            </a:r>
-          </a:p>
-        </p:txBody>
-      </p:sp>
+              <a:t>3</a:t>
+            </a:r>
+          </a:p>
+        </p:txBody>
+      </p:sp>
+      <p:pic>
+        <p:nvPicPr>
+          <p:cNvPr id="9" name="Picture 8" descr="A yellow and black square with a check mark&#10;&#10;AI-generated content may be incorrect.">
+            <a:extLst>
+              <a:ext uri="{FF2B5EF4-FFF2-40B4-BE49-F238E27FC236}">
+                <a16:creationId xmlns:a16="http://schemas.microsoft.com/office/drawing/2014/main" id="{9C05A78F-805E-8B99-BA66-C84E5F176754}"/>
+              </a:ext>
+            </a:extLst>
+          </p:cNvPr>
+          <p:cNvPicPr>
+            <a:picLocks noChangeAspect="1"/>
+          </p:cNvPicPr>
+          <p:nvPr/>
+        </p:nvPicPr>
+        <p:blipFill>
+          <a:blip r:embed="rId2"/>
+          <a:stretch>
+            <a:fillRect/>
+          </a:stretch>
+        </p:blipFill>
+        <p:spPr>
+          <a:xfrm>
+            <a:off x="474218" y="194056"/>
+            <a:ext cx="697484" cy="697484"/>
+          </a:xfrm>
+          <a:prstGeom prst="rect">
+            <a:avLst/>
+          </a:prstGeom>
+        </p:spPr>
+      </p:pic>
     </p:spTree>
   </p:cSld>
   <p:clrMapOvr>
@@ -4448,8 +5556,8 @@
 </p:sld>
 </file>
 
-<file path=ppt/slides/slide3.xml><?xml version="1.0" encoding="utf-8"?>
-<p:sld xmlns:a="http://schemas.openxmlformats.org/drawingml/2006/main" xmlns:p="http://schemas.openxmlformats.org/presentationml/2006/main" xmlns:r="http://schemas.openxmlformats.org/officeDocument/2006/relationships">
+<file path=ppt/slides/slide4.xml><?xml version="1.0" encoding="utf-8"?>
+<p:sld xmlns:a="http://schemas.openxmlformats.org/drawingml/2006/main" xmlns:r="http://schemas.openxmlformats.org/officeDocument/2006/relationships" xmlns:p="http://schemas.openxmlformats.org/presentationml/2006/main">
   <p:cSld>
     <p:bg>
       <p:bgPr>
@@ -4465,7 +5573,14 @@
         <p:cNvGrpSpPr/>
         <p:nvPr/>
       </p:nvGrpSpPr>
-      <p:grpSpPr/>
+      <p:grpSpPr>
+        <a:xfrm>
+          <a:off x="0" y="0"/>
+          <a:ext cx="0" cy="0"/>
+          <a:chOff x="0" y="0"/>
+          <a:chExt cx="0" cy="0"/>
+        </a:xfrm>
+      </p:grpSpPr>
       <p:sp>
         <p:nvSpPr>
           <p:cNvPr id="2" name="Rectangle 1"/>
@@ -4506,6 +5621,7 @@
           <a:lstStyle/>
           <a:p>
             <a:pPr algn="ctr"/>
+            <a:endParaRPr/>
           </a:p>
         </p:txBody>
       </p:sp>
@@ -4569,11 +5685,11 @@
             <a:r>
               <a:rPr sz="1300" b="1">
                 <a:solidFill>
-                  <a:srgbClr val="5FB6AD"/>
-                </a:solidFill>
-                <a:latin typeface="Arial"/>
-              </a:rPr>
-              <a:t>THE SOLUTION</a:t>
+                  <a:srgbClr val="E0B64D"/>
+                </a:solidFill>
+                <a:latin typeface="Arial"/>
+              </a:rPr>
+              <a:t>HOW IT WORKS</a:t>
             </a:r>
           </a:p>
         </p:txBody>
@@ -4607,7 +5723,7 @@
                 </a:solidFill>
                 <a:latin typeface="Arial"/>
               </a:rPr>
-              <a:t>Your context, everywhere — and it stays yours.</a:t>
+              <a:t>Two tiers, decided on-device.</a:t>
             </a:r>
           </a:p>
         </p:txBody>
@@ -4621,7 +5737,7 @@
         <p:spPr>
           <a:xfrm>
             <a:off x="822960" y="2651760"/>
-            <a:ext cx="10515600" cy="3474720"/>
+            <a:ext cx="10515600" cy="1559401"/>
           </a:xfrm>
           <a:prstGeom prst="rect">
             <a:avLst/>
@@ -4640,31 +5756,49 @@
               </a:spcAft>
             </a:pPr>
             <a:r>
-              <a:rPr sz="1800" b="1">
-                <a:solidFill>
-                  <a:srgbClr val="5FB6AD"/>
+              <a:rPr sz="1800" b="1" dirty="0">
+                <a:solidFill>
+                  <a:srgbClr val="E0B64D"/>
                 </a:solidFill>
                 <a:latin typeface="Arial"/>
               </a:rPr>
               <a:t>— </a:t>
             </a:r>
             <a:r>
-              <a:rPr sz="1800" b="1">
+              <a:rPr sz="1800" b="1" dirty="0">
                 <a:solidFill>
                   <a:srgbClr val="ECEAE4"/>
                 </a:solidFill>
                 <a:latin typeface="Arial"/>
               </a:rPr>
-              <a:t>Portable.</a:t>
-            </a:r>
-            <a:r>
-              <a:rPr sz="1800" b="0">
+              <a:t>Crown-Jewels Gateway.</a:t>
+            </a:r>
+            <a:r>
+              <a:rPr sz="1800" b="0" dirty="0">
                 <a:solidFill>
                   <a:srgbClr val="CFCDC7"/>
                 </a:solidFill>
                 <a:latin typeface="Arial"/>
               </a:rPr>
-              <a:t>  One context layer that works across every AI, not locked inside one.</a:t>
+              <a:t>  On-device </a:t>
+            </a:r>
+            <a:r>
+              <a:rPr lang="en-US" sz="1800" b="0" dirty="0">
+                <a:solidFill>
+                  <a:srgbClr val="CFCDC7"/>
+                </a:solidFill>
+                <a:latin typeface="Arial"/>
+              </a:rPr>
+              <a:t>Finetuned </a:t>
+            </a:r>
+            <a:r>
+              <a:rPr sz="1800" b="0" dirty="0">
+                <a:solidFill>
+                  <a:srgbClr val="CFCDC7"/>
+                </a:solidFill>
+                <a:latin typeface="Arial"/>
+              </a:rPr>
+              <a:t>Gemma 3 270M + deterministic rules classify every item.</a:t>
             </a:r>
           </a:p>
           <a:p>
@@ -4674,31 +5808,31 @@
               </a:spcAft>
             </a:pPr>
             <a:r>
-              <a:rPr sz="1800" b="1">
-                <a:solidFill>
-                  <a:srgbClr val="5FB6AD"/>
+              <a:rPr sz="1800" b="1" dirty="0">
+                <a:solidFill>
+                  <a:srgbClr val="E0B64D"/>
                 </a:solidFill>
                 <a:latin typeface="Arial"/>
               </a:rPr>
               <a:t>— </a:t>
             </a:r>
             <a:r>
-              <a:rPr sz="1800" b="1">
+              <a:rPr sz="1800" b="1" dirty="0">
                 <a:solidFill>
                   <a:srgbClr val="ECEAE4"/>
                 </a:solidFill>
                 <a:latin typeface="Arial"/>
               </a:rPr>
-              <a:t>Private by default.</a:t>
-            </a:r>
-            <a:r>
-              <a:rPr sz="1800" b="0">
+              <a:t>PRIVATE (gold).</a:t>
+            </a:r>
+            <a:r>
+              <a:rPr sz="1800" b="0" dirty="0">
                 <a:solidFill>
                   <a:srgbClr val="CFCDC7"/>
                 </a:solidFill>
                 <a:latin typeface="Arial"/>
               </a:rPr>
-              <a:t>  A Crown-Jewels Gateway keeps sensitive context on your device.</a:t>
+              <a:t>  Kept on-device, end-to-end encrypted. The cloud is a blind relay of ciphertext.</a:t>
             </a:r>
           </a:p>
           <a:p>
@@ -4708,31 +5842,31 @@
               </a:spcAft>
             </a:pPr>
             <a:r>
-              <a:rPr sz="1800" b="1">
-                <a:solidFill>
-                  <a:srgbClr val="5FB6AD"/>
+              <a:rPr sz="1800" b="1" dirty="0">
+                <a:solidFill>
+                  <a:srgbClr val="E0B64D"/>
                 </a:solidFill>
                 <a:latin typeface="Arial"/>
               </a:rPr>
               <a:t>— </a:t>
             </a:r>
             <a:r>
-              <a:rPr sz="1800" b="1">
+              <a:rPr sz="1800" b="1" dirty="0">
                 <a:solidFill>
                   <a:srgbClr val="ECEAE4"/>
                 </a:solidFill>
                 <a:latin typeface="Arial"/>
               </a:rPr>
-              <a:t>Consumer-first.</a:t>
-            </a:r>
-            <a:r>
-              <a:rPr sz="1800" b="0">
+              <a:t>SHARED (patina).</a:t>
+            </a:r>
+            <a:r>
+              <a:rPr sz="1800" b="0" dirty="0">
                 <a:solidFill>
                   <a:srgbClr val="CFCDC7"/>
                 </a:solidFill>
                 <a:latin typeface="Arial"/>
               </a:rPr>
-              <a:t>  The piece nobody built: memory that follows you and protects you.</a:t>
+              <a:t>  Distilled into reusable context cards any AI can read over MCP.</a:t>
             </a:r>
           </a:p>
         </p:txBody>
@@ -4801,11 +5935,41 @@
                 </a:solidFill>
                 <a:latin typeface="Arial"/>
               </a:rPr>
-              <a:t>3</a:t>
-            </a:r>
-          </a:p>
-        </p:txBody>
-      </p:sp>
+              <a:t>4</a:t>
+            </a:r>
+          </a:p>
+        </p:txBody>
+      </p:sp>
+      <p:pic>
+        <p:nvPicPr>
+          <p:cNvPr id="9" name="Picture 8" descr="A yellow and black square with a check mark&#10;&#10;AI-generated content may be incorrect.">
+            <a:extLst>
+              <a:ext uri="{FF2B5EF4-FFF2-40B4-BE49-F238E27FC236}">
+                <a16:creationId xmlns:a16="http://schemas.microsoft.com/office/drawing/2014/main" id="{6374E2DA-69B0-1115-8666-3B90F047AF9E}"/>
+              </a:ext>
+            </a:extLst>
+          </p:cNvPr>
+          <p:cNvPicPr>
+            <a:picLocks noChangeAspect="1"/>
+          </p:cNvPicPr>
+          <p:nvPr/>
+        </p:nvPicPr>
+        <p:blipFill>
+          <a:blip r:embed="rId2"/>
+          <a:stretch>
+            <a:fillRect/>
+          </a:stretch>
+        </p:blipFill>
+        <p:spPr>
+          <a:xfrm>
+            <a:off x="474218" y="194056"/>
+            <a:ext cx="697484" cy="697484"/>
+          </a:xfrm>
+          <a:prstGeom prst="rect">
+            <a:avLst/>
+          </a:prstGeom>
+        </p:spPr>
+      </p:pic>
     </p:spTree>
   </p:cSld>
   <p:clrMapOvr>
@@ -4814,8 +5978,8 @@
 </p:sld>
 </file>
 
-<file path=ppt/slides/slide4.xml><?xml version="1.0" encoding="utf-8"?>
-<p:sld xmlns:a="http://schemas.openxmlformats.org/drawingml/2006/main" xmlns:p="http://schemas.openxmlformats.org/presentationml/2006/main" xmlns:r="http://schemas.openxmlformats.org/officeDocument/2006/relationships">
+<file path=ppt/slides/slide5.xml><?xml version="1.0" encoding="utf-8"?>
+<p:sld xmlns:a="http://schemas.openxmlformats.org/drawingml/2006/main" xmlns:r="http://schemas.openxmlformats.org/officeDocument/2006/relationships" xmlns:p="http://schemas.openxmlformats.org/presentationml/2006/main">
   <p:cSld>
     <p:bg>
       <p:bgPr>
@@ -4831,7 +5995,14 @@
         <p:cNvGrpSpPr/>
         <p:nvPr/>
       </p:nvGrpSpPr>
-      <p:grpSpPr/>
+      <p:grpSpPr>
+        <a:xfrm>
+          <a:off x="0" y="0"/>
+          <a:ext cx="0" cy="0"/>
+          <a:chOff x="0" y="0"/>
+          <a:chExt cx="0" cy="0"/>
+        </a:xfrm>
+      </p:grpSpPr>
       <p:sp>
         <p:nvSpPr>
           <p:cNvPr id="2" name="Rectangle 1"/>
@@ -4872,6 +6043,7 @@
           <a:lstStyle/>
           <a:p>
             <a:pPr algn="ctr"/>
+            <a:endParaRPr/>
           </a:p>
         </p:txBody>
       </p:sp>
@@ -4939,7 +6111,7 @@
                 </a:solidFill>
                 <a:latin typeface="Arial"/>
               </a:rPr>
-              <a:t>HOW IT WORKS</a:t>
+              <a:t>THE PRODUCT</a:t>
             </a:r>
           </a:p>
         </p:txBody>
@@ -4973,7 +6145,7 @@
                 </a:solidFill>
                 <a:latin typeface="Arial"/>
               </a:rPr>
-              <a:t>Two tiers, decided on-device.</a:t>
+              <a:t>A browser extension that plugs into your life.</a:t>
             </a:r>
           </a:p>
         </p:txBody>
@@ -5021,7 +6193,7 @@
                 </a:solidFill>
                 <a:latin typeface="Arial"/>
               </a:rPr>
-              <a:t>Crown-Jewels Gateway.</a:t>
+              <a:t>Connect.</a:t>
             </a:r>
             <a:r>
               <a:rPr sz="1800" b="0">
@@ -5030,7 +6202,7 @@
                 </a:solidFill>
                 <a:latin typeface="Arial"/>
               </a:rPr>
-              <a:t>  On-device Gemma 3 270M + deterministic rules classify every item.</a:t>
+              <a:t>  Gmail, Calendar &amp; Notion via in-extension OAuth.</a:t>
             </a:r>
           </a:p>
           <a:p>
@@ -5055,7 +6227,7 @@
                 </a:solidFill>
                 <a:latin typeface="Arial"/>
               </a:rPr>
-              <a:t>PRIVATE (gold).</a:t>
+              <a:t>Tier on-device.</a:t>
             </a:r>
             <a:r>
               <a:rPr sz="1800" b="0">
@@ -5064,7 +6236,7 @@
                 </a:solidFill>
                 <a:latin typeface="Arial"/>
               </a:rPr>
-              <a:t>  Kept on-device, end-to-end encrypted. The cloud is a blind relay of ciphertext.</a:t>
+              <a:t>  Every pulled item is classified locally — SHARED shown, PRIVATE kept &amp; counted.</a:t>
             </a:r>
           </a:p>
           <a:p>
@@ -5089,7 +6261,7 @@
                 </a:solidFill>
                 <a:latin typeface="Arial"/>
               </a:rPr>
-              <a:t>SHARED (patina).</a:t>
+              <a:t>Your choice.</a:t>
             </a:r>
             <a:r>
               <a:rPr sz="1800" b="0">
@@ -5098,7 +6270,7 @@
                 </a:solidFill>
                 <a:latin typeface="Arial"/>
               </a:rPr>
-              <a:t>  Distilled into reusable context cards any AI can read over MCP.</a:t>
+              <a:t>  On-device mode (WebGPU Gemma) or online-only — nothing private stored.</a:t>
             </a:r>
           </a:p>
         </p:txBody>
@@ -5167,11 +6339,41 @@
                 </a:solidFill>
                 <a:latin typeface="Arial"/>
               </a:rPr>
-              <a:t>4</a:t>
-            </a:r>
-          </a:p>
-        </p:txBody>
-      </p:sp>
+              <a:t>5</a:t>
+            </a:r>
+          </a:p>
+        </p:txBody>
+      </p:sp>
+      <p:pic>
+        <p:nvPicPr>
+          <p:cNvPr id="9" name="Picture 8" descr="A yellow and black square with a check mark&#10;&#10;AI-generated content may be incorrect.">
+            <a:extLst>
+              <a:ext uri="{FF2B5EF4-FFF2-40B4-BE49-F238E27FC236}">
+                <a16:creationId xmlns:a16="http://schemas.microsoft.com/office/drawing/2014/main" id="{378A0EF0-FAD5-0535-4B0C-8E2703F2C37B}"/>
+              </a:ext>
+            </a:extLst>
+          </p:cNvPr>
+          <p:cNvPicPr>
+            <a:picLocks noChangeAspect="1"/>
+          </p:cNvPicPr>
+          <p:nvPr/>
+        </p:nvPicPr>
+        <p:blipFill>
+          <a:blip r:embed="rId2"/>
+          <a:stretch>
+            <a:fillRect/>
+          </a:stretch>
+        </p:blipFill>
+        <p:spPr>
+          <a:xfrm>
+            <a:off x="474218" y="194056"/>
+            <a:ext cx="697484" cy="697484"/>
+          </a:xfrm>
+          <a:prstGeom prst="rect">
+            <a:avLst/>
+          </a:prstGeom>
+        </p:spPr>
+      </p:pic>
     </p:spTree>
   </p:cSld>
   <p:clrMapOvr>
@@ -5180,8 +6382,8 @@
 </p:sld>
 </file>
 
-<file path=ppt/slides/slide5.xml><?xml version="1.0" encoding="utf-8"?>
-<p:sld xmlns:a="http://schemas.openxmlformats.org/drawingml/2006/main" xmlns:p="http://schemas.openxmlformats.org/presentationml/2006/main" xmlns:r="http://schemas.openxmlformats.org/officeDocument/2006/relationships">
+<file path=ppt/slides/slide6.xml><?xml version="1.0" encoding="utf-8"?>
+<p:sld xmlns:a="http://schemas.openxmlformats.org/drawingml/2006/main" xmlns:r="http://schemas.openxmlformats.org/officeDocument/2006/relationships" xmlns:p="http://schemas.openxmlformats.org/presentationml/2006/main">
   <p:cSld>
     <p:bg>
       <p:bgPr>
@@ -5197,7 +6399,14 @@
         <p:cNvGrpSpPr/>
         <p:nvPr/>
       </p:nvGrpSpPr>
-      <p:grpSpPr/>
+      <p:grpSpPr>
+        <a:xfrm>
+          <a:off x="0" y="0"/>
+          <a:ext cx="0" cy="0"/>
+          <a:chOff x="0" y="0"/>
+          <a:chExt cx="0" cy="0"/>
+        </a:xfrm>
+      </p:grpSpPr>
       <p:sp>
         <p:nvSpPr>
           <p:cNvPr id="2" name="Rectangle 1"/>
@@ -5238,6 +6447,7 @@
           <a:lstStyle/>
           <a:p>
             <a:pPr algn="ctr"/>
+            <a:endParaRPr/>
           </a:p>
         </p:txBody>
       </p:sp>
@@ -5305,7 +6515,7 @@
                 </a:solidFill>
                 <a:latin typeface="Arial"/>
               </a:rPr>
-              <a:t>THE PRODUCT</a:t>
+              <a:t>THE PAYOFF</a:t>
             </a:r>
           </a:p>
         </p:txBody>
@@ -5339,7 +6549,7 @@
                 </a:solidFill>
                 <a:latin typeface="Arial"/>
               </a:rPr>
-              <a:t>A browser extension that plugs into your life.</a:t>
+              <a:t>It injects your context into any AI, live.</a:t>
             </a:r>
           </a:p>
         </p:txBody>
@@ -5387,7 +6597,7 @@
                 </a:solidFill>
                 <a:latin typeface="Arial"/>
               </a:rPr>
-              <a:t>Connect.</a:t>
+              <a:t>Auto-inject.</a:t>
             </a:r>
             <a:r>
               <a:rPr sz="1800" b="0">
@@ -5396,7 +6606,7 @@
                 </a:solidFill>
                 <a:latin typeface="Arial"/>
               </a:rPr>
-              <a:t>  Gmail, Calendar &amp; Notion via in-extension OAuth.</a:t>
+              <a:t>  Open Claude / ChatGPT / Gemini — your SHARED context lands in the composer.</a:t>
             </a:r>
           </a:p>
           <a:p>
@@ -5421,7 +6631,7 @@
                 </a:solidFill>
                 <a:latin typeface="Arial"/>
               </a:rPr>
-              <a:t>Tier on-device.</a:t>
+              <a:t>Visible trust.</a:t>
             </a:r>
             <a:r>
               <a:rPr sz="1800" b="0">
@@ -5430,7 +6640,7 @@
                 </a:solidFill>
                 <a:latin typeface="Arial"/>
               </a:rPr>
-              <a:t>  Every pulled item is classified locally — SHARED shown, PRIVATE kept &amp; counted.</a:t>
+              <a:t>  A badge shows 'N shared → this AI · P private kept on-device'.</a:t>
             </a:r>
           </a:p>
           <a:p>
@@ -5455,7 +6665,7 @@
                 </a:solidFill>
                 <a:latin typeface="Arial"/>
               </a:rPr>
-              <a:t>Your choice.</a:t>
+              <a:t>The guarantee.</a:t>
             </a:r>
             <a:r>
               <a:rPr sz="1800" b="0">
@@ -5464,7 +6674,7 @@
                 </a:solidFill>
                 <a:latin typeface="Arial"/>
               </a:rPr>
-              <a:t>  On-device mode (WebGPU Gemma) or online-only — nothing private stored.</a:t>
+              <a:t>  The AI answers with your context and never sees the crown jewels.</a:t>
             </a:r>
           </a:p>
         </p:txBody>
@@ -5533,11 +6743,41 @@
                 </a:solidFill>
                 <a:latin typeface="Arial"/>
               </a:rPr>
-              <a:t>5</a:t>
-            </a:r>
-          </a:p>
-        </p:txBody>
-      </p:sp>
+              <a:t>6</a:t>
+            </a:r>
+          </a:p>
+        </p:txBody>
+      </p:sp>
+      <p:pic>
+        <p:nvPicPr>
+          <p:cNvPr id="9" name="Picture 8" descr="A yellow and black square with a check mark&#10;&#10;AI-generated content may be incorrect.">
+            <a:extLst>
+              <a:ext uri="{FF2B5EF4-FFF2-40B4-BE49-F238E27FC236}">
+                <a16:creationId xmlns:a16="http://schemas.microsoft.com/office/drawing/2014/main" id="{105354FC-299B-8F86-6991-755A8C6D3ED9}"/>
+              </a:ext>
+            </a:extLst>
+          </p:cNvPr>
+          <p:cNvPicPr>
+            <a:picLocks noChangeAspect="1"/>
+          </p:cNvPicPr>
+          <p:nvPr/>
+        </p:nvPicPr>
+        <p:blipFill>
+          <a:blip r:embed="rId2"/>
+          <a:stretch>
+            <a:fillRect/>
+          </a:stretch>
+        </p:blipFill>
+        <p:spPr>
+          <a:xfrm>
+            <a:off x="474218" y="194056"/>
+            <a:ext cx="697484" cy="697484"/>
+          </a:xfrm>
+          <a:prstGeom prst="rect">
+            <a:avLst/>
+          </a:prstGeom>
+        </p:spPr>
+      </p:pic>
     </p:spTree>
   </p:cSld>
   <p:clrMapOvr>
@@ -5546,8 +6786,8 @@
 </p:sld>
 </file>
 
-<file path=ppt/slides/slide6.xml><?xml version="1.0" encoding="utf-8"?>
-<p:sld xmlns:a="http://schemas.openxmlformats.org/drawingml/2006/main" xmlns:p="http://schemas.openxmlformats.org/presentationml/2006/main" xmlns:r="http://schemas.openxmlformats.org/officeDocument/2006/relationships">
+<file path=ppt/slides/slide7.xml><?xml version="1.0" encoding="utf-8"?>
+<p:sld xmlns:a="http://schemas.openxmlformats.org/drawingml/2006/main" xmlns:r="http://schemas.openxmlformats.org/officeDocument/2006/relationships" xmlns:p="http://schemas.openxmlformats.org/presentationml/2006/main">
   <p:cSld>
     <p:bg>
       <p:bgPr>
@@ -5563,7 +6803,14 @@
         <p:cNvGrpSpPr/>
         <p:nvPr/>
       </p:nvGrpSpPr>
-      <p:grpSpPr/>
+      <p:grpSpPr>
+        <a:xfrm>
+          <a:off x="0" y="0"/>
+          <a:ext cx="0" cy="0"/>
+          <a:chOff x="0" y="0"/>
+          <a:chExt cx="0" cy="0"/>
+        </a:xfrm>
+      </p:grpSpPr>
       <p:sp>
         <p:nvSpPr>
           <p:cNvPr id="2" name="Rectangle 1"/>
@@ -5604,6 +6851,7 @@
           <a:lstStyle/>
           <a:p>
             <a:pPr algn="ctr"/>
+            <a:endParaRPr/>
           </a:p>
         </p:txBody>
       </p:sp>
@@ -5671,7 +6919,7 @@
                 </a:solidFill>
                 <a:latin typeface="Arial"/>
               </a:rPr>
-              <a:t>THE PAYOFF</a:t>
+              <a:t>PRIVACY, PROVEN</a:t>
             </a:r>
           </a:p>
         </p:txBody>
@@ -5705,7 +6953,7 @@
                 </a:solidFill>
                 <a:latin typeface="Arial"/>
               </a:rPr>
-              <a:t>It injects your context into any AI, live.</a:t>
+              <a:t>The cloud never holds your keys.</a:t>
             </a:r>
           </a:p>
         </p:txBody>
@@ -5753,7 +7001,7 @@
                 </a:solidFill>
                 <a:latin typeface="Arial"/>
               </a:rPr>
-              <a:t>Auto-inject.</a:t>
+              <a:t>Ciphertext only.</a:t>
             </a:r>
             <a:r>
               <a:rPr sz="1800" b="0">
@@ -5762,7 +7010,7 @@
                 </a:solidFill>
                 <a:latin typeface="Arial"/>
               </a:rPr>
-              <a:t>  Open Claude / ChatGPT / Gemini — your SHARED context lands in the composer.</a:t>
+              <a:t>  PRIVATE cards sit in the cloud as opaque AES-256-GCM blobs.</a:t>
             </a:r>
           </a:p>
           <a:p>
@@ -5787,7 +7035,7 @@
                 </a:solidFill>
                 <a:latin typeface="Arial"/>
               </a:rPr>
-              <a:t>Visible trust.</a:t>
+              <a:t>Key by QR.</a:t>
             </a:r>
             <a:r>
               <a:rPr sz="1800" b="0">
@@ -5796,7 +7044,7 @@
                 </a:solidFill>
                 <a:latin typeface="Arial"/>
               </a:rPr>
-              <a:t>  A badge shows 'N shared → this AI · P private kept on-device'.</a:t>
+              <a:t>  Moving devices? The key crosses device-to-device by QR, never the cloud.</a:t>
             </a:r>
           </a:p>
           <a:p>
@@ -5821,7 +7069,7 @@
                 </a:solidFill>
                 <a:latin typeface="Arial"/>
               </a:rPr>
-              <a:t>The guarantee.</a:t>
+              <a:t>Decrypt locally.</a:t>
             </a:r>
             <a:r>
               <a:rPr sz="1800" b="0">
@@ -5830,7 +7078,7 @@
                 </a:solidFill>
                 <a:latin typeface="Arial"/>
               </a:rPr>
-              <a:t>  The AI answers with your context and never sees the crown jewels.</a:t>
+              <a:t>  A second device pulls the same blob and decrypts it — byte-for-byte.</a:t>
             </a:r>
           </a:p>
         </p:txBody>
@@ -5899,11 +7147,41 @@
                 </a:solidFill>
                 <a:latin typeface="Arial"/>
               </a:rPr>
-              <a:t>6</a:t>
-            </a:r>
-          </a:p>
-        </p:txBody>
-      </p:sp>
+              <a:t>7</a:t>
+            </a:r>
+          </a:p>
+        </p:txBody>
+      </p:sp>
+      <p:pic>
+        <p:nvPicPr>
+          <p:cNvPr id="9" name="Picture 8" descr="A yellow and black square with a check mark&#10;&#10;AI-generated content may be incorrect.">
+            <a:extLst>
+              <a:ext uri="{FF2B5EF4-FFF2-40B4-BE49-F238E27FC236}">
+                <a16:creationId xmlns:a16="http://schemas.microsoft.com/office/drawing/2014/main" id="{75753F67-CDD8-63C4-8936-9FCCD8592D03}"/>
+              </a:ext>
+            </a:extLst>
+          </p:cNvPr>
+          <p:cNvPicPr>
+            <a:picLocks noChangeAspect="1"/>
+          </p:cNvPicPr>
+          <p:nvPr/>
+        </p:nvPicPr>
+        <p:blipFill>
+          <a:blip r:embed="rId2"/>
+          <a:stretch>
+            <a:fillRect/>
+          </a:stretch>
+        </p:blipFill>
+        <p:spPr>
+          <a:xfrm>
+            <a:off x="474218" y="194056"/>
+            <a:ext cx="697484" cy="697484"/>
+          </a:xfrm>
+          <a:prstGeom prst="rect">
+            <a:avLst/>
+          </a:prstGeom>
+        </p:spPr>
+      </p:pic>
     </p:spTree>
   </p:cSld>
   <p:clrMapOvr>
@@ -5912,8 +7190,8 @@
 </p:sld>
 </file>
 
-<file path=ppt/slides/slide7.xml><?xml version="1.0" encoding="utf-8"?>
-<p:sld xmlns:a="http://schemas.openxmlformats.org/drawingml/2006/main" xmlns:p="http://schemas.openxmlformats.org/presentationml/2006/main" xmlns:r="http://schemas.openxmlformats.org/officeDocument/2006/relationships">
+<file path=ppt/slides/slide8.xml><?xml version="1.0" encoding="utf-8"?>
+<p:sld xmlns:a="http://schemas.openxmlformats.org/drawingml/2006/main" xmlns:r="http://schemas.openxmlformats.org/officeDocument/2006/relationships" xmlns:p="http://schemas.openxmlformats.org/presentationml/2006/main">
   <p:cSld>
     <p:bg>
       <p:bgPr>
@@ -5929,7 +7207,14 @@
         <p:cNvGrpSpPr/>
         <p:nvPr/>
       </p:nvGrpSpPr>
-      <p:grpSpPr/>
+      <p:grpSpPr>
+        <a:xfrm>
+          <a:off x="0" y="0"/>
+          <a:ext cx="0" cy="0"/>
+          <a:chOff x="0" y="0"/>
+          <a:chExt cx="0" cy="0"/>
+        </a:xfrm>
+      </p:grpSpPr>
       <p:sp>
         <p:nvSpPr>
           <p:cNvPr id="2" name="Rectangle 1"/>
@@ -5970,6 +7255,7 @@
           <a:lstStyle/>
           <a:p>
             <a:pPr algn="ctr"/>
+            <a:endParaRPr/>
           </a:p>
         </p:txBody>
       </p:sp>
@@ -6033,11 +7319,11 @@
             <a:r>
               <a:rPr sz="1300" b="1">
                 <a:solidFill>
-                  <a:srgbClr val="E0B64D"/>
-                </a:solidFill>
-                <a:latin typeface="Arial"/>
-              </a:rPr>
-              <a:t>PRIVACY, PROVEN</a:t>
+                  <a:srgbClr val="5FB6AD"/>
+                </a:solidFill>
+                <a:latin typeface="Arial"/>
+              </a:rPr>
+              <a:t>ONE PRODUCT</a:t>
             </a:r>
           </a:p>
         </p:txBody>
@@ -6071,7 +7357,7 @@
                 </a:solidFill>
                 <a:latin typeface="Arial"/>
               </a:rPr>
-              <a:t>The cloud never holds your keys.</a:t>
+              <a:t>A web dashboard that mirrors the extension.</a:t>
             </a:r>
           </a:p>
         </p:txBody>
@@ -6106,7 +7392,7 @@
             <a:r>
               <a:rPr sz="1800" b="1">
                 <a:solidFill>
-                  <a:srgbClr val="E0B64D"/>
+                  <a:srgbClr val="5FB6AD"/>
                 </a:solidFill>
                 <a:latin typeface="Arial"/>
               </a:rPr>
@@ -6119,7 +7405,7 @@
                 </a:solidFill>
                 <a:latin typeface="Arial"/>
               </a:rPr>
-              <a:t>Ciphertext only.</a:t>
+              <a:t>Deployed &amp; live.</a:t>
             </a:r>
             <a:r>
               <a:rPr sz="1800" b="0">
@@ -6128,7 +7414,7 @@
                 </a:solidFill>
                 <a:latin typeface="Arial"/>
               </a:rPr>
-              <a:t>  PRIVATE cards sit in the cloud as opaque AES-256-GCM blobs.</a:t>
+              <a:t>  blackx16.github.io/contxt — a static SvelteKit app on GitHub Pages.</a:t>
             </a:r>
           </a:p>
           <a:p>
@@ -6140,7 +7426,7 @@
             <a:r>
               <a:rPr sz="1800" b="1">
                 <a:solidFill>
-                  <a:srgbClr val="E0B64D"/>
+                  <a:srgbClr val="5FB6AD"/>
                 </a:solidFill>
                 <a:latin typeface="Arial"/>
               </a:rPr>
@@ -6153,7 +7439,7 @@
                 </a:solidFill>
                 <a:latin typeface="Arial"/>
               </a:rPr>
-              <a:t>Key by QR.</a:t>
+              <a:t>Demo / Live toggle.</a:t>
             </a:r>
             <a:r>
               <a:rPr sz="1800" b="0">
@@ -6162,7 +7448,7 @@
                 </a:solidFill>
                 <a:latin typeface="Arial"/>
               </a:rPr>
-              <a:t>  Moving devices? The key crosses device-to-device by QR, never the cloud.</a:t>
+              <a:t>  Explore a built-in demo, or read your real context from the extension.</a:t>
             </a:r>
           </a:p>
           <a:p>
@@ -6174,7 +7460,7 @@
             <a:r>
               <a:rPr sz="1800" b="1">
                 <a:solidFill>
-                  <a:srgbClr val="E0B64D"/>
+                  <a:srgbClr val="5FB6AD"/>
                 </a:solidFill>
                 <a:latin typeface="Arial"/>
               </a:rPr>
@@ -6187,7 +7473,7 @@
                 </a:solidFill>
                 <a:latin typeface="Arial"/>
               </a:rPr>
-              <a:t>Decrypt locally.</a:t>
+              <a:t>Real-time bridge.</a:t>
             </a:r>
             <a:r>
               <a:rPr sz="1800" b="0">
@@ -6196,7 +7482,7 @@
                 </a:solidFill>
                 <a:latin typeface="Arial"/>
               </a:rPr>
-              <a:t>  A second device pulls the same blob and decrypts it — byte-for-byte.</a:t>
+              <a:t>  Connect a source in the extension → the site updates instantly.</a:t>
             </a:r>
           </a:p>
         </p:txBody>
@@ -6265,11 +7551,41 @@
                 </a:solidFill>
                 <a:latin typeface="Arial"/>
               </a:rPr>
-              <a:t>7</a:t>
-            </a:r>
-          </a:p>
-        </p:txBody>
-      </p:sp>
+              <a:t>8</a:t>
+            </a:r>
+          </a:p>
+        </p:txBody>
+      </p:sp>
+      <p:pic>
+        <p:nvPicPr>
+          <p:cNvPr id="9" name="Picture 8" descr="A yellow and black square with a check mark&#10;&#10;AI-generated content may be incorrect.">
+            <a:extLst>
+              <a:ext uri="{FF2B5EF4-FFF2-40B4-BE49-F238E27FC236}">
+                <a16:creationId xmlns:a16="http://schemas.microsoft.com/office/drawing/2014/main" id="{86359324-286D-3C3C-19F3-87942409A7C5}"/>
+              </a:ext>
+            </a:extLst>
+          </p:cNvPr>
+          <p:cNvPicPr>
+            <a:picLocks noChangeAspect="1"/>
+          </p:cNvPicPr>
+          <p:nvPr/>
+        </p:nvPicPr>
+        <p:blipFill>
+          <a:blip r:embed="rId2"/>
+          <a:stretch>
+            <a:fillRect/>
+          </a:stretch>
+        </p:blipFill>
+        <p:spPr>
+          <a:xfrm>
+            <a:off x="474218" y="194056"/>
+            <a:ext cx="697484" cy="697484"/>
+          </a:xfrm>
+          <a:prstGeom prst="rect">
+            <a:avLst/>
+          </a:prstGeom>
+        </p:spPr>
+      </p:pic>
     </p:spTree>
   </p:cSld>
   <p:clrMapOvr>
@@ -6278,8 +7594,8 @@
 </p:sld>
 </file>
 
-<file path=ppt/slides/slide8.xml><?xml version="1.0" encoding="utf-8"?>
-<p:sld xmlns:a="http://schemas.openxmlformats.org/drawingml/2006/main" xmlns:p="http://schemas.openxmlformats.org/presentationml/2006/main" xmlns:r="http://schemas.openxmlformats.org/officeDocument/2006/relationships">
+<file path=ppt/slides/slide9.xml><?xml version="1.0" encoding="utf-8"?>
+<p:sld xmlns:a="http://schemas.openxmlformats.org/drawingml/2006/main" xmlns:r="http://schemas.openxmlformats.org/officeDocument/2006/relationships" xmlns:p="http://schemas.openxmlformats.org/presentationml/2006/main">
   <p:cSld>
     <p:bg>
       <p:bgPr>
@@ -6295,7 +7611,14 @@
         <p:cNvGrpSpPr/>
         <p:nvPr/>
       </p:nvGrpSpPr>
-      <p:grpSpPr/>
+      <p:grpSpPr>
+        <a:xfrm>
+          <a:off x="0" y="0"/>
+          <a:ext cx="0" cy="0"/>
+          <a:chOff x="0" y="0"/>
+          <a:chExt cx="0" cy="0"/>
+        </a:xfrm>
+      </p:grpSpPr>
       <p:sp>
         <p:nvSpPr>
           <p:cNvPr id="2" name="Rectangle 1"/>
@@ -6336,6 +7659,7 @@
           <a:lstStyle/>
           <a:p>
             <a:pPr algn="ctr"/>
+            <a:endParaRPr/>
           </a:p>
         </p:txBody>
       </p:sp>
@@ -6399,11 +7723,11 @@
             <a:r>
               <a:rPr sz="1300" b="1">
                 <a:solidFill>
-                  <a:srgbClr val="5FB6AD"/>
-                </a:solidFill>
-                <a:latin typeface="Arial"/>
-              </a:rPr>
-              <a:t>ONE PRODUCT</a:t>
+                  <a:srgbClr val="E0B64D"/>
+                </a:solidFill>
+                <a:latin typeface="Arial"/>
+              </a:rPr>
+              <a:t>UNDER THE HOOD</a:t>
             </a:r>
           </a:p>
         </p:txBody>
@@ -6437,7 +7761,7 @@
                 </a:solidFill>
                 <a:latin typeface="Arial"/>
               </a:rPr>
-              <a:t>A web dashboard that mirrors the extension.</a:t>
+              <a:t>Small, portable, open.</a:t>
             </a:r>
           </a:p>
         </p:txBody>
@@ -6472,7 +7796,7 @@
             <a:r>
               <a:rPr sz="1800" b="1">
                 <a:solidFill>
-                  <a:srgbClr val="5FB6AD"/>
+                  <a:srgbClr val="E0B64D"/>
                 </a:solidFill>
                 <a:latin typeface="Arial"/>
               </a:rPr>
@@ -6485,7 +7809,7 @@
                 </a:solidFill>
                 <a:latin typeface="Arial"/>
               </a:rPr>
-              <a:t>Deployed &amp; live.</a:t>
+              <a:t>On-device:</a:t>
             </a:r>
             <a:r>
               <a:rPr sz="1800" b="0">
@@ -6494,7 +7818,7 @@
                 </a:solidFill>
                 <a:latin typeface="Arial"/>
               </a:rPr>
-              <a:t>  blackx16.github.io/contxt — a static SvelteKit app on GitHub Pages.</a:t>
+              <a:t>  Fine-tuned Gemma 3 270M (ONNX q4f16) via Transformers.js; deterministic-rules safety floor.</a:t>
             </a:r>
           </a:p>
           <a:p>
@@ -6506,7 +7830,7 @@
             <a:r>
               <a:rPr sz="1800" b="1">
                 <a:solidFill>
-                  <a:srgbClr val="5FB6AD"/>
+                  <a:srgbClr val="E0B64D"/>
                 </a:solidFill>
                 <a:latin typeface="Arial"/>
               </a:rPr>
@@ -6519,7 +7843,7 @@
                 </a:solidFill>
                 <a:latin typeface="Arial"/>
               </a:rPr>
-              <a:t>Demo / Live toggle.</a:t>
+              <a:t>Cloud distill:</a:t>
             </a:r>
             <a:r>
               <a:rPr sz="1800" b="0">
@@ -6528,7 +7852,7 @@
                 </a:solidFill>
                 <a:latin typeface="Arial"/>
               </a:rPr>
-              <a:t>  Explore a built-in demo, or read your real context from the extension.</a:t>
+              <a:t>  gpt-oss-120B on Fireworks AI (SHARED tier → context cards + draft_reply).</a:t>
             </a:r>
           </a:p>
           <a:p>
@@ -6540,7 +7864,7 @@
             <a:r>
               <a:rPr sz="1800" b="1">
                 <a:solidFill>
-                  <a:srgbClr val="5FB6AD"/>
+                  <a:srgbClr val="E0B64D"/>
                 </a:solidFill>
                 <a:latin typeface="Arial"/>
               </a:rPr>
@@ -6553,7 +7877,7 @@
                 </a:solidFill>
                 <a:latin typeface="Arial"/>
               </a:rPr>
-              <a:t>Real-time bridge.</a:t>
+              <a:t>Stack:</a:t>
             </a:r>
             <a:r>
               <a:rPr sz="1800" b="0">
@@ -6562,7 +7886,7 @@
                 </a:solidFill>
                 <a:latin typeface="Arial"/>
               </a:rPr>
-              <a:t>  Connect a source in the extension → the site updates instantly.</a:t>
+              <a:t>  SvelteKit · MV3 extension · Python MCP server + HTTP bridge · Web Crypto · public Docker image (GHCR).</a:t>
             </a:r>
           </a:p>
         </p:txBody>
@@ -6631,377 +7955,41 @@
                 </a:solidFill>
                 <a:latin typeface="Arial"/>
               </a:rPr>
-              <a:t>8</a:t>
-            </a:r>
-          </a:p>
-        </p:txBody>
-      </p:sp>
-    </p:spTree>
-  </p:cSld>
-  <p:clrMapOvr>
-    <a:masterClrMapping/>
-  </p:clrMapOvr>
-</p:sld>
-</file>
-
-<file path=ppt/slides/slide9.xml><?xml version="1.0" encoding="utf-8"?>
-<p:sld xmlns:a="http://schemas.openxmlformats.org/drawingml/2006/main" xmlns:p="http://schemas.openxmlformats.org/presentationml/2006/main" xmlns:r="http://schemas.openxmlformats.org/officeDocument/2006/relationships">
-  <p:cSld>
-    <p:bg>
-      <p:bgPr>
-        <a:solidFill>
-          <a:srgbClr val="0E0E10"/>
-        </a:solidFill>
-        <a:effectLst/>
-      </p:bgPr>
-    </p:bg>
-    <p:spTree>
-      <p:nvGrpSpPr>
-        <p:cNvPr id="1" name=""/>
-        <p:cNvGrpSpPr/>
-        <p:nvPr/>
-      </p:nvGrpSpPr>
-      <p:grpSpPr/>
-      <p:sp>
-        <p:nvSpPr>
-          <p:cNvPr id="2" name="Rectangle 1"/>
-          <p:cNvSpPr/>
+              <a:t>9</a:t>
+            </a:r>
+          </a:p>
+        </p:txBody>
+      </p:sp>
+      <p:pic>
+        <p:nvPicPr>
+          <p:cNvPr id="9" name="Picture 8" descr="A yellow and black square with a check mark&#10;&#10;AI-generated content may be incorrect.">
+            <a:extLst>
+              <a:ext uri="{FF2B5EF4-FFF2-40B4-BE49-F238E27FC236}">
+                <a16:creationId xmlns:a16="http://schemas.microsoft.com/office/drawing/2014/main" id="{C25AD2EE-E18D-6EEA-823E-DFBED1241B3F}"/>
+              </a:ext>
+            </a:extLst>
+          </p:cNvPr>
+          <p:cNvPicPr>
+            <a:picLocks noChangeAspect="1"/>
+          </p:cNvPicPr>
           <p:nvPr/>
-        </p:nvSpPr>
-        <p:spPr>
-          <a:xfrm>
-            <a:off x="822960" y="502920"/>
-            <a:ext cx="237744" cy="237744"/>
+        </p:nvPicPr>
+        <p:blipFill>
+          <a:blip r:embed="rId2"/>
+          <a:stretch>
+            <a:fillRect/>
+          </a:stretch>
+        </p:blipFill>
+        <p:spPr>
+          <a:xfrm>
+            <a:off x="474218" y="194056"/>
+            <a:ext cx="697484" cy="697484"/>
           </a:xfrm>
           <a:prstGeom prst="rect">
             <a:avLst/>
           </a:prstGeom>
-          <a:noFill/>
-          <a:ln w="25400">
-            <a:solidFill>
-              <a:srgbClr val="E0B64D"/>
-            </a:solidFill>
-          </a:ln>
-        </p:spPr>
-        <p:style>
-          <a:lnRef idx="1">
-            <a:schemeClr val="accent1"/>
-          </a:lnRef>
-          <a:fillRef idx="3">
-            <a:schemeClr val="accent1"/>
-          </a:fillRef>
-          <a:effectRef idx="2">
-            <a:schemeClr val="accent1"/>
-          </a:effectRef>
-          <a:fontRef idx="minor">
-            <a:schemeClr val="lt1"/>
-          </a:fontRef>
-        </p:style>
-        <p:txBody>
-          <a:bodyPr rtlCol="0" anchor="ctr"/>
-          <a:lstStyle/>
-          <a:p>
-            <a:pPr algn="ctr"/>
-          </a:p>
-        </p:txBody>
-      </p:sp>
-      <p:cxnSp>
-        <p:nvCxnSpPr>
-          <p:cNvPr id="3" name="Connector 2"/>
-          <p:cNvCxnSpPr/>
-          <p:nvPr/>
-        </p:nvCxnSpPr>
-        <p:spPr>
-          <a:xfrm flipH="1">
-            <a:off x="822960" y="502920"/>
-            <a:ext cx="237744" cy="237744"/>
-          </a:xfrm>
-          <a:prstGeom prst="bentConnector3">
-            <a:avLst/>
-          </a:prstGeom>
-          <a:ln w="25400">
-            <a:solidFill>
-              <a:srgbClr val="E0B64D"/>
-            </a:solidFill>
-          </a:ln>
-        </p:spPr>
-        <p:style>
-          <a:lnRef idx="2">
-            <a:schemeClr val="accent1"/>
-          </a:lnRef>
-          <a:fillRef idx="0">
-            <a:schemeClr val="accent1"/>
-          </a:fillRef>
-          <a:effectRef idx="1">
-            <a:schemeClr val="accent1"/>
-          </a:effectRef>
-          <a:fontRef idx="minor">
-            <a:schemeClr val="tx1"/>
-          </a:fontRef>
-        </p:style>
-      </p:cxnSp>
-      <p:sp>
-        <p:nvSpPr>
-          <p:cNvPr id="4" name="TextBox 3"/>
-          <p:cNvSpPr txBox="1"/>
-          <p:nvPr/>
-        </p:nvSpPr>
-        <p:spPr>
-          <a:xfrm>
-            <a:off x="822960" y="914400"/>
-            <a:ext cx="10515600" cy="365760"/>
-          </a:xfrm>
-          <a:prstGeom prst="rect">
-            <a:avLst/>
-          </a:prstGeom>
-          <a:noFill/>
-        </p:spPr>
-        <p:txBody>
-          <a:bodyPr wrap="square">
-            <a:spAutoFit/>
-          </a:bodyPr>
-          <a:lstStyle/>
-          <a:p>
-            <a:r>
-              <a:rPr sz="1300" b="1">
-                <a:solidFill>
-                  <a:srgbClr val="E0B64D"/>
-                </a:solidFill>
-                <a:latin typeface="Arial"/>
-              </a:rPr>
-              <a:t>UNDER THE HOOD</a:t>
-            </a:r>
-          </a:p>
-        </p:txBody>
-      </p:sp>
-      <p:sp>
-        <p:nvSpPr>
-          <p:cNvPr id="5" name="TextBox 4"/>
-          <p:cNvSpPr txBox="1"/>
-          <p:nvPr/>
-        </p:nvSpPr>
-        <p:spPr>
-          <a:xfrm>
-            <a:off x="822960" y="1325880"/>
-            <a:ext cx="10515600" cy="1188720"/>
-          </a:xfrm>
-          <a:prstGeom prst="rect">
-            <a:avLst/>
-          </a:prstGeom>
-          <a:noFill/>
-        </p:spPr>
-        <p:txBody>
-          <a:bodyPr wrap="square">
-            <a:spAutoFit/>
-          </a:bodyPr>
-          <a:lstStyle/>
-          <a:p>
-            <a:r>
-              <a:rPr sz="3400" b="1">
-                <a:solidFill>
-                  <a:srgbClr val="ECEAE4"/>
-                </a:solidFill>
-                <a:latin typeface="Arial"/>
-              </a:rPr>
-              <a:t>Small, portable, open.</a:t>
-            </a:r>
-          </a:p>
-        </p:txBody>
-      </p:sp>
-      <p:sp>
-        <p:nvSpPr>
-          <p:cNvPr id="6" name="TextBox 5"/>
-          <p:cNvSpPr txBox="1"/>
-          <p:nvPr/>
-        </p:nvSpPr>
-        <p:spPr>
-          <a:xfrm>
-            <a:off x="822960" y="2651760"/>
-            <a:ext cx="10515600" cy="3474720"/>
-          </a:xfrm>
-          <a:prstGeom prst="rect">
-            <a:avLst/>
-          </a:prstGeom>
-          <a:noFill/>
-        </p:spPr>
-        <p:txBody>
-          <a:bodyPr wrap="square">
-            <a:spAutoFit/>
-          </a:bodyPr>
-          <a:lstStyle/>
-          <a:p>
-            <a:pPr>
-              <a:spcAft>
-                <a:spcPts val="1400"/>
-              </a:spcAft>
-            </a:pPr>
-            <a:r>
-              <a:rPr sz="1800" b="1">
-                <a:solidFill>
-                  <a:srgbClr val="E0B64D"/>
-                </a:solidFill>
-                <a:latin typeface="Arial"/>
-              </a:rPr>
-              <a:t>— </a:t>
-            </a:r>
-            <a:r>
-              <a:rPr sz="1800" b="1">
-                <a:solidFill>
-                  <a:srgbClr val="ECEAE4"/>
-                </a:solidFill>
-                <a:latin typeface="Arial"/>
-              </a:rPr>
-              <a:t>On-device:</a:t>
-            </a:r>
-            <a:r>
-              <a:rPr sz="1800" b="0">
-                <a:solidFill>
-                  <a:srgbClr val="CFCDC7"/>
-                </a:solidFill>
-                <a:latin typeface="Arial"/>
-              </a:rPr>
-              <a:t>  Fine-tuned Gemma 3 270M (ONNX q4f16) via Transformers.js; deterministic-rules safety floor.</a:t>
-            </a:r>
-          </a:p>
-          <a:p>
-            <a:pPr>
-              <a:spcAft>
-                <a:spcPts val="1400"/>
-              </a:spcAft>
-            </a:pPr>
-            <a:r>
-              <a:rPr sz="1800" b="1">
-                <a:solidFill>
-                  <a:srgbClr val="E0B64D"/>
-                </a:solidFill>
-                <a:latin typeface="Arial"/>
-              </a:rPr>
-              <a:t>— </a:t>
-            </a:r>
-            <a:r>
-              <a:rPr sz="1800" b="1">
-                <a:solidFill>
-                  <a:srgbClr val="ECEAE4"/>
-                </a:solidFill>
-                <a:latin typeface="Arial"/>
-              </a:rPr>
-              <a:t>Cloud distill:</a:t>
-            </a:r>
-            <a:r>
-              <a:rPr sz="1800" b="0">
-                <a:solidFill>
-                  <a:srgbClr val="CFCDC7"/>
-                </a:solidFill>
-                <a:latin typeface="Arial"/>
-              </a:rPr>
-              <a:t>  gpt-oss-120B on Fireworks AI (SHARED tier → context cards + draft_reply).</a:t>
-            </a:r>
-          </a:p>
-          <a:p>
-            <a:pPr>
-              <a:spcAft>
-                <a:spcPts val="1400"/>
-              </a:spcAft>
-            </a:pPr>
-            <a:r>
-              <a:rPr sz="1800" b="1">
-                <a:solidFill>
-                  <a:srgbClr val="E0B64D"/>
-                </a:solidFill>
-                <a:latin typeface="Arial"/>
-              </a:rPr>
-              <a:t>— </a:t>
-            </a:r>
-            <a:r>
-              <a:rPr sz="1800" b="1">
-                <a:solidFill>
-                  <a:srgbClr val="ECEAE4"/>
-                </a:solidFill>
-                <a:latin typeface="Arial"/>
-              </a:rPr>
-              <a:t>Stack:</a:t>
-            </a:r>
-            <a:r>
-              <a:rPr sz="1800" b="0">
-                <a:solidFill>
-                  <a:srgbClr val="CFCDC7"/>
-                </a:solidFill>
-                <a:latin typeface="Arial"/>
-              </a:rPr>
-              <a:t>  SvelteKit · MV3 extension · Python MCP server + HTTP bridge · Web Crypto · public Docker image (GHCR).</a:t>
-            </a:r>
-          </a:p>
-        </p:txBody>
-      </p:sp>
-      <p:sp>
-        <p:nvSpPr>
-          <p:cNvPr id="7" name="TextBox 6"/>
-          <p:cNvSpPr txBox="1"/>
-          <p:nvPr/>
-        </p:nvSpPr>
-        <p:spPr>
-          <a:xfrm>
-            <a:off x="822960" y="6355080"/>
-            <a:ext cx="10515600" cy="365760"/>
-          </a:xfrm>
-          <a:prstGeom prst="rect">
-            <a:avLst/>
-          </a:prstGeom>
-          <a:noFill/>
-        </p:spPr>
-        <p:txBody>
-          <a:bodyPr wrap="square">
-            <a:spAutoFit/>
-          </a:bodyPr>
-          <a:lstStyle/>
-          <a:p>
-            <a:r>
-              <a:rPr sz="1000" b="1">
-                <a:solidFill>
-                  <a:srgbClr val="9A9892"/>
-                </a:solidFill>
-                <a:latin typeface="Arial"/>
-              </a:rPr>
-              <a:t>CONTXT</a:t>
-            </a:r>
-          </a:p>
-        </p:txBody>
-      </p:sp>
-      <p:sp>
-        <p:nvSpPr>
-          <p:cNvPr id="8" name="TextBox 7"/>
-          <p:cNvSpPr txBox="1"/>
-          <p:nvPr/>
-        </p:nvSpPr>
-        <p:spPr>
-          <a:xfrm>
-            <a:off x="10789920" y="6355080"/>
-            <a:ext cx="1097280" cy="365760"/>
-          </a:xfrm>
-          <a:prstGeom prst="rect">
-            <a:avLst/>
-          </a:prstGeom>
-          <a:noFill/>
-        </p:spPr>
-        <p:txBody>
-          <a:bodyPr wrap="square">
-            <a:spAutoFit/>
-          </a:bodyPr>
-          <a:lstStyle/>
-          <a:p>
-            <a:pPr algn="r"/>
-            <a:r>
-              <a:rPr sz="1000" b="0">
-                <a:solidFill>
-                  <a:srgbClr val="9A9892"/>
-                </a:solidFill>
-                <a:latin typeface="Arial"/>
-              </a:rPr>
-              <a:t>9</a:t>
-            </a:r>
-          </a:p>
-        </p:txBody>
-      </p:sp>
+        </p:spPr>
+      </p:pic>
     </p:spTree>
   </p:cSld>
   <p:clrMapOvr>
@@ -7328,4 +8316,319 @@
   </a:objectDefaults>
   <a:extraClrSchemeLst/>
 </a:theme>
+</file>
+
+<file path=ppt/theme/theme2.xml><?xml version="1.0" encoding="utf-8"?>
+<a:theme xmlns:a="http://schemas.openxmlformats.org/drawingml/2006/main" name="Office Theme">
+  <a:themeElements>
+    <a:clrScheme name="Office">
+      <a:dk1>
+        <a:sysClr val="windowText" lastClr="000000"/>
+      </a:dk1>
+      <a:lt1>
+        <a:sysClr val="window" lastClr="FFFFFF"/>
+      </a:lt1>
+      <a:dk2>
+        <a:srgbClr val="0E2841"/>
+      </a:dk2>
+      <a:lt2>
+        <a:srgbClr val="E8E8E8"/>
+      </a:lt2>
+      <a:accent1>
+        <a:srgbClr val="156082"/>
+      </a:accent1>
+      <a:accent2>
+        <a:srgbClr val="E97132"/>
+      </a:accent2>
+      <a:accent3>
+        <a:srgbClr val="196B24"/>
+      </a:accent3>
+      <a:accent4>
+        <a:srgbClr val="0F9ED5"/>
+      </a:accent4>
+      <a:accent5>
+        <a:srgbClr val="A02B93"/>
+      </a:accent5>
+      <a:accent6>
+        <a:srgbClr val="4EA72E"/>
+      </a:accent6>
+      <a:hlink>
+        <a:srgbClr val="467886"/>
+      </a:hlink>
+      <a:folHlink>
+        <a:srgbClr val="96607D"/>
+      </a:folHlink>
+    </a:clrScheme>
+    <a:fontScheme name="Office">
+      <a:majorFont>
+        <a:latin typeface="Aptos Display" panose="02110004020202020204"/>
+        <a:ea typeface=""/>
+        <a:cs typeface=""/>
+        <a:font script="Jpan" typeface="游ゴシック Light"/>
+        <a:font script="Hang" typeface="맑은 고딕"/>
+        <a:font script="Hans" typeface="等线 Light"/>
+        <a:font script="Hant" typeface="新細明體"/>
+        <a:font script="Arab" typeface="Times New Roman"/>
+        <a:font script="Hebr" typeface="Times New Roman"/>
+        <a:font script="Thai" typeface="Angsana New"/>
+        <a:font script="Ethi" typeface="Nyala"/>
+        <a:font script="Beng" typeface="Vrinda"/>
+        <a:font script="Gujr" typeface="Shruti"/>
+        <a:font script="Khmr" typeface="MoolBoran"/>
+        <a:font script="Knda" typeface="Tunga"/>
+        <a:font script="Guru" typeface="Raavi"/>
+        <a:font script="Cans" typeface="Euphemia"/>
+        <a:font script="Cher" typeface="Plantagenet Cherokee"/>
+        <a:font script="Yiii" typeface="Microsoft Yi Baiti"/>
+        <a:font script="Tibt" typeface="Microsoft Himalaya"/>
+        <a:font script="Thaa" typeface="MV Boli"/>
+        <a:font script="Deva" typeface="Mangal"/>
+        <a:font script="Telu" typeface="Gautami"/>
+        <a:font script="Taml" typeface="Latha"/>
+        <a:font script="Syrc" typeface="Estrangelo Edessa"/>
+        <a:font script="Orya" typeface="Kalinga"/>
+        <a:font script="Mlym" typeface="Kartika"/>
+        <a:font script="Laoo" typeface="DokChampa"/>
+        <a:font script="Sinh" typeface="Iskoola Pota"/>
+        <a:font script="Mong" typeface="Mongolian Baiti"/>
+        <a:font script="Viet" typeface="Times New Roman"/>
+        <a:font script="Uigh" typeface="Microsoft Uighur"/>
+        <a:font script="Geor" typeface="Sylfaen"/>
+        <a:font script="Armn" typeface="Arial"/>
+        <a:font script="Bugi" typeface="Leelawadee UI"/>
+        <a:font script="Bopo" typeface="Microsoft JhengHei"/>
+        <a:font script="Java" typeface="Javanese Text"/>
+        <a:font script="Lisu" typeface="Segoe UI"/>
+        <a:font script="Mymr" typeface="Myanmar Text"/>
+        <a:font script="Nkoo" typeface="Ebrima"/>
+        <a:font script="Olck" typeface="Nirmala UI"/>
+        <a:font script="Osma" typeface="Ebrima"/>
+        <a:font script="Phag" typeface="Phagspa"/>
+        <a:font script="Syrn" typeface="Estrangelo Edessa"/>
+        <a:font script="Syrj" typeface="Estrangelo Edessa"/>
+        <a:font script="Syre" typeface="Estrangelo Edessa"/>
+        <a:font script="Sora" typeface="Nirmala UI"/>
+        <a:font script="Tale" typeface="Microsoft Tai Le"/>
+        <a:font script="Talu" typeface="Microsoft New Tai Lue"/>
+        <a:font script="Tfng" typeface="Ebrima"/>
+      </a:majorFont>
+      <a:minorFont>
+        <a:latin typeface="Aptos" panose="02110004020202020204"/>
+        <a:ea typeface=""/>
+        <a:cs typeface=""/>
+        <a:font script="Jpan" typeface="游ゴシック"/>
+        <a:font script="Hang" typeface="맑은 고딕"/>
+        <a:font script="Hans" typeface="等线"/>
+        <a:font script="Hant" typeface="新細明體"/>
+        <a:font script="Arab" typeface="Arial"/>
+        <a:font script="Hebr" typeface="Arial"/>
+        <a:font script="Thai" typeface="Cordia New"/>
+        <a:font script="Ethi" typeface="Nyala"/>
+        <a:font script="Beng" typeface="Vrinda"/>
+        <a:font script="Gujr" typeface="Shruti"/>
+        <a:font script="Khmr" typeface="DaunPenh"/>
+        <a:font script="Knda" typeface="Tunga"/>
+        <a:font script="Guru" typeface="Raavi"/>
+        <a:font script="Cans" typeface="Euphemia"/>
+        <a:font script="Cher" typeface="Plantagenet Cherokee"/>
+        <a:font script="Yiii" typeface="Microsoft Yi Baiti"/>
+        <a:font script="Tibt" typeface="Microsoft Himalaya"/>
+        <a:font script="Thaa" typeface="MV Boli"/>
+        <a:font script="Deva" typeface="Mangal"/>
+        <a:font script="Telu" typeface="Gautami"/>
+        <a:font script="Taml" typeface="Latha"/>
+        <a:font script="Syrc" typeface="Estrangelo Edessa"/>
+        <a:font script="Orya" typeface="Kalinga"/>
+        <a:font script="Mlym" typeface="Kartika"/>
+        <a:font script="Laoo" typeface="DokChampa"/>
+        <a:font script="Sinh" typeface="Iskoola Pota"/>
+        <a:font script="Mong" typeface="Mongolian Baiti"/>
+        <a:font script="Viet" typeface="Arial"/>
+        <a:font script="Uigh" typeface="Microsoft Uighur"/>
+        <a:font script="Geor" typeface="Sylfaen"/>
+        <a:font script="Armn" typeface="Arial"/>
+        <a:font script="Bugi" typeface="Leelawadee UI"/>
+        <a:font script="Bopo" typeface="Microsoft JhengHei"/>
+        <a:font script="Java" typeface="Javanese Text"/>
+        <a:font script="Lisu" typeface="Segoe UI"/>
+        <a:font script="Mymr" typeface="Myanmar Text"/>
+        <a:font script="Nkoo" typeface="Ebrima"/>
+        <a:font script="Olck" typeface="Nirmala UI"/>
+        <a:font script="Osma" typeface="Ebrima"/>
+        <a:font script="Phag" typeface="Phagspa"/>
+        <a:font script="Syrn" typeface="Estrangelo Edessa"/>
+        <a:font script="Syrj" typeface="Estrangelo Edessa"/>
+        <a:font script="Syre" typeface="Estrangelo Edessa"/>
+        <a:font script="Sora" typeface="Nirmala UI"/>
+        <a:font script="Tale" typeface="Microsoft Tai Le"/>
+        <a:font script="Talu" typeface="Microsoft New Tai Lue"/>
+        <a:font script="Tfng" typeface="Ebrima"/>
+      </a:minorFont>
+    </a:fontScheme>
+    <a:fmtScheme name="Office">
+      <a:fillStyleLst>
+        <a:solidFill>
+          <a:schemeClr val="phClr"/>
+        </a:solidFill>
+        <a:gradFill rotWithShape="1">
+          <a:gsLst>
+            <a:gs pos="0">
+              <a:schemeClr val="phClr">
+                <a:lumMod val="110000"/>
+                <a:satMod val="105000"/>
+                <a:tint val="67000"/>
+              </a:schemeClr>
+            </a:gs>
+            <a:gs pos="50000">
+              <a:schemeClr val="phClr">
+                <a:lumMod val="105000"/>
+                <a:satMod val="103000"/>
+                <a:tint val="73000"/>
+              </a:schemeClr>
+            </a:gs>
+            <a:gs pos="100000">
+              <a:schemeClr val="phClr">
+                <a:lumMod val="105000"/>
+                <a:satMod val="109000"/>
+                <a:tint val="81000"/>
+              </a:schemeClr>
+            </a:gs>
+          </a:gsLst>
+          <a:lin ang="5400000" scaled="0"/>
+        </a:gradFill>
+        <a:gradFill rotWithShape="1">
+          <a:gsLst>
+            <a:gs pos="0">
+              <a:schemeClr val="phClr">
+                <a:satMod val="103000"/>
+                <a:lumMod val="102000"/>
+                <a:tint val="94000"/>
+              </a:schemeClr>
+            </a:gs>
+            <a:gs pos="50000">
+              <a:schemeClr val="phClr">
+                <a:satMod val="110000"/>
+                <a:lumMod val="100000"/>
+                <a:shade val="100000"/>
+              </a:schemeClr>
+            </a:gs>
+            <a:gs pos="100000">
+              <a:schemeClr val="phClr">
+                <a:lumMod val="99000"/>
+                <a:satMod val="120000"/>
+                <a:shade val="78000"/>
+              </a:schemeClr>
+            </a:gs>
+          </a:gsLst>
+          <a:lin ang="5400000" scaled="0"/>
+        </a:gradFill>
+      </a:fillStyleLst>
+      <a:lnStyleLst>
+        <a:ln w="12700" cap="flat" cmpd="sng" algn="ctr">
+          <a:solidFill>
+            <a:schemeClr val="phClr"/>
+          </a:solidFill>
+          <a:prstDash val="solid"/>
+          <a:miter lim="800000"/>
+        </a:ln>
+        <a:ln w="19050" cap="flat" cmpd="sng" algn="ctr">
+          <a:solidFill>
+            <a:schemeClr val="phClr"/>
+          </a:solidFill>
+          <a:prstDash val="solid"/>
+          <a:miter lim="800000"/>
+        </a:ln>
+        <a:ln w="25400" cap="flat" cmpd="sng" algn="ctr">
+          <a:solidFill>
+            <a:schemeClr val="phClr"/>
+          </a:solidFill>
+          <a:prstDash val="solid"/>
+          <a:miter lim="800000"/>
+        </a:ln>
+      </a:lnStyleLst>
+      <a:effectStyleLst>
+        <a:effectStyle>
+          <a:effectLst/>
+        </a:effectStyle>
+        <a:effectStyle>
+          <a:effectLst/>
+        </a:effectStyle>
+        <a:effectStyle>
+          <a:effectLst>
+            <a:outerShdw blurRad="57150" dist="19050" dir="5400000" algn="ctr" rotWithShape="0">
+              <a:srgbClr val="000000">
+                <a:alpha val="63000"/>
+              </a:srgbClr>
+            </a:outerShdw>
+          </a:effectLst>
+        </a:effectStyle>
+      </a:effectStyleLst>
+      <a:bgFillStyleLst>
+        <a:solidFill>
+          <a:schemeClr val="phClr"/>
+        </a:solidFill>
+        <a:solidFill>
+          <a:schemeClr val="phClr">
+            <a:tint val="95000"/>
+            <a:satMod val="170000"/>
+          </a:schemeClr>
+        </a:solidFill>
+        <a:gradFill rotWithShape="1">
+          <a:gsLst>
+            <a:gs pos="0">
+              <a:schemeClr val="phClr">
+                <a:tint val="93000"/>
+                <a:satMod val="150000"/>
+                <a:shade val="98000"/>
+                <a:lumMod val="102000"/>
+              </a:schemeClr>
+            </a:gs>
+            <a:gs pos="50000">
+              <a:schemeClr val="phClr">
+                <a:tint val="98000"/>
+                <a:satMod val="130000"/>
+                <a:shade val="90000"/>
+                <a:lumMod val="103000"/>
+              </a:schemeClr>
+            </a:gs>
+            <a:gs pos="100000">
+              <a:schemeClr val="phClr">
+                <a:shade val="63000"/>
+                <a:satMod val="120000"/>
+              </a:schemeClr>
+            </a:gs>
+          </a:gsLst>
+          <a:lin ang="5400000" scaled="0"/>
+        </a:gradFill>
+      </a:bgFillStyleLst>
+    </a:fmtScheme>
+  </a:themeElements>
+  <a:objectDefaults>
+    <a:lnDef>
+      <a:spPr/>
+      <a:bodyPr/>
+      <a:lstStyle/>
+      <a:style>
+        <a:lnRef idx="2">
+          <a:schemeClr val="accent1"/>
+        </a:lnRef>
+        <a:fillRef idx="0">
+          <a:schemeClr val="accent1"/>
+        </a:fillRef>
+        <a:effectRef idx="1">
+          <a:schemeClr val="accent1"/>
+        </a:effectRef>
+        <a:fontRef idx="minor">
+          <a:schemeClr val="tx1"/>
+        </a:fontRef>
+      </a:style>
+    </a:lnDef>
+  </a:objectDefaults>
+  <a:extraClrSchemeLst/>
+  <a:extLst>
+    <a:ext uri="{05A4C25C-085E-4340-85A3-A5531E510DB2}">
+      <thm15:themeFamily xmlns:thm15="http://schemas.microsoft.com/office/thememl/2012/main" name="Office Theme" id="{2E142A2C-CD16-42D6-873A-C26D2A0506FA}" vid="{1BDDFF52-6CD6-40A5-AB3C-68EB2F1E4D0A}"/>
+    </a:ext>
+  </a:extLst>
+</a:theme>
 </file>
</xml_diff>